<commit_message>
Reframe project as personal variant confidence classifier
</commit_message>
<xml_diff>
--- a/reports/variant-confidence-hust-report.pptx
+++ b/reports/variant-confidence-hust-report.pptx
@@ -2,22 +2,22 @@
 <file path=ppt/presentation.xml><?xml version="1.0" encoding="utf-8"?>
 <p:presentation xmlns:p="http://schemas.openxmlformats.org/presentationml/2006/main">
   <p:sldMasterIdLst>
-    <p:sldMasterId xmlns:r="http://schemas.openxmlformats.org/officeDocument/2006/relationships" id="2147483648" r:id="R941dcbb79db749d6"/>
+    <p:sldMasterId xmlns:r="http://schemas.openxmlformats.org/officeDocument/2006/relationships" id="2147483648" r:id="Rfa07d948e42943e2"/>
   </p:sldMasterIdLst>
   <p:notesMasterIdLst>
-    <p:notesMasterId xmlns:r="http://schemas.openxmlformats.org/officeDocument/2006/relationships" r:id="Rbe415f2b46c8484d"/>
+    <p:notesMasterId xmlns:r="http://schemas.openxmlformats.org/officeDocument/2006/relationships" r:id="R20062d355a294df6"/>
   </p:notesMasterIdLst>
   <p:sldIdLst>
-    <p:sldId xmlns:r="http://schemas.openxmlformats.org/officeDocument/2006/relationships" id="256" r:id="R47fe8d8534114186"/>
-    <p:sldId xmlns:r="http://schemas.openxmlformats.org/officeDocument/2006/relationships" id="257" r:id="R4797efcab556415a"/>
-    <p:sldId xmlns:r="http://schemas.openxmlformats.org/officeDocument/2006/relationships" id="258" r:id="R3e3d5f82b4ae4742"/>
-    <p:sldId xmlns:r="http://schemas.openxmlformats.org/officeDocument/2006/relationships" id="259" r:id="R3a717c5512d74090"/>
-    <p:sldId xmlns:r="http://schemas.openxmlformats.org/officeDocument/2006/relationships" id="260" r:id="Rcc109b0f25c34cbf"/>
-    <p:sldId xmlns:r="http://schemas.openxmlformats.org/officeDocument/2006/relationships" id="261" r:id="R73eb16a5f2d04e02"/>
-    <p:sldId xmlns:r="http://schemas.openxmlformats.org/officeDocument/2006/relationships" id="262" r:id="Rb4e673b5978a4bab"/>
-    <p:sldId xmlns:r="http://schemas.openxmlformats.org/officeDocument/2006/relationships" id="263" r:id="Rdebf7428cd624a9b"/>
-    <p:sldId xmlns:r="http://schemas.openxmlformats.org/officeDocument/2006/relationships" id="264" r:id="Re0c22f0600734b45"/>
-    <p:sldId xmlns:r="http://schemas.openxmlformats.org/officeDocument/2006/relationships" id="265" r:id="Re06480388b9a43bb"/>
+    <p:sldId xmlns:r="http://schemas.openxmlformats.org/officeDocument/2006/relationships" id="256" r:id="R9fc444929ca245e8"/>
+    <p:sldId xmlns:r="http://schemas.openxmlformats.org/officeDocument/2006/relationships" id="257" r:id="R5724d1e26aec4ba3"/>
+    <p:sldId xmlns:r="http://schemas.openxmlformats.org/officeDocument/2006/relationships" id="258" r:id="Ra014c311896a4f49"/>
+    <p:sldId xmlns:r="http://schemas.openxmlformats.org/officeDocument/2006/relationships" id="259" r:id="R8942240949d242dd"/>
+    <p:sldId xmlns:r="http://schemas.openxmlformats.org/officeDocument/2006/relationships" id="260" r:id="Rf131883e6a404622"/>
+    <p:sldId xmlns:r="http://schemas.openxmlformats.org/officeDocument/2006/relationships" id="261" r:id="R816e95da8c9640a6"/>
+    <p:sldId xmlns:r="http://schemas.openxmlformats.org/officeDocument/2006/relationships" id="262" r:id="Rd484ee1641244e62"/>
+    <p:sldId xmlns:r="http://schemas.openxmlformats.org/officeDocument/2006/relationships" id="263" r:id="Rd2c9805709de4a77"/>
+    <p:sldId xmlns:r="http://schemas.openxmlformats.org/officeDocument/2006/relationships" id="264" r:id="Ra27f35aa95ed426a"/>
+    <p:sldId xmlns:r="http://schemas.openxmlformats.org/officeDocument/2006/relationships" id="265" r:id="R0db2f78fcd4641c0"/>
   </p:sldIdLst>
   <p:sldSz cx="9144000" cy="6858000"/>
   <p:notesSz cx="6858000" cy="9144000"/>
@@ -3993,19 +3993,19 @@
   </p:cSld>
   <p:clrMap bg1="lt1" tx1="dk1" bg2="lt2" tx2="dk2" accent1="accent1" accent2="accent2" accent3="accent3" accent4="accent4" accent5="accent5" accent6="accent6" hlink="hlink" folHlink="folHlink"/>
   <p:sldLayoutIdLst>
-    <p:sldLayoutId xmlns:r="http://schemas.openxmlformats.org/officeDocument/2006/relationships" id="2147483649" r:id="R166f4a9741fb4a91"/>
-    <p:sldLayoutId xmlns:r="http://schemas.openxmlformats.org/officeDocument/2006/relationships" id="2147483650" r:id="R25fddd039fe1403c"/>
-    <p:sldLayoutId xmlns:r="http://schemas.openxmlformats.org/officeDocument/2006/relationships" id="2147483651" r:id="R7f8c06fcce764ca4"/>
-    <p:sldLayoutId xmlns:r="http://schemas.openxmlformats.org/officeDocument/2006/relationships" id="2147483652" r:id="R10e524209a794c08"/>
-    <p:sldLayoutId xmlns:r="http://schemas.openxmlformats.org/officeDocument/2006/relationships" id="2147483653" r:id="Raa50119a6f314b03"/>
-    <p:sldLayoutId xmlns:r="http://schemas.openxmlformats.org/officeDocument/2006/relationships" id="2147483654" r:id="Rec408bccd3cc4bb8"/>
-    <p:sldLayoutId xmlns:r="http://schemas.openxmlformats.org/officeDocument/2006/relationships" id="2147483655" r:id="Rfa6e00d108994e60"/>
-    <p:sldLayoutId xmlns:r="http://schemas.openxmlformats.org/officeDocument/2006/relationships" id="2147483656" r:id="R493167d2f8274cf2"/>
-    <p:sldLayoutId xmlns:r="http://schemas.openxmlformats.org/officeDocument/2006/relationships" id="2147483657" r:id="Rc388e3dacfdc453f"/>
-    <p:sldLayoutId xmlns:r="http://schemas.openxmlformats.org/officeDocument/2006/relationships" id="2147483658" r:id="Rd73357b82bc84b2e"/>
-    <p:sldLayoutId xmlns:r="http://schemas.openxmlformats.org/officeDocument/2006/relationships" id="2147483659" r:id="Re248f7fd782f4591"/>
-    <p:sldLayoutId xmlns:r="http://schemas.openxmlformats.org/officeDocument/2006/relationships" id="2147483660" r:id="Rb561b958a41f47c0"/>
-    <p:sldLayoutId xmlns:r="http://schemas.openxmlformats.org/officeDocument/2006/relationships" id="2147483661" r:id="R4c171e6a910e4d02"/>
+    <p:sldLayoutId xmlns:r="http://schemas.openxmlformats.org/officeDocument/2006/relationships" id="2147483649" r:id="R52ef9df5c86a4512"/>
+    <p:sldLayoutId xmlns:r="http://schemas.openxmlformats.org/officeDocument/2006/relationships" id="2147483650" r:id="R6126642f6b584187"/>
+    <p:sldLayoutId xmlns:r="http://schemas.openxmlformats.org/officeDocument/2006/relationships" id="2147483651" r:id="R60e853ecce19408e"/>
+    <p:sldLayoutId xmlns:r="http://schemas.openxmlformats.org/officeDocument/2006/relationships" id="2147483652" r:id="Rda16813e55f14bc1"/>
+    <p:sldLayoutId xmlns:r="http://schemas.openxmlformats.org/officeDocument/2006/relationships" id="2147483653" r:id="Rf7a11eb3e25e4912"/>
+    <p:sldLayoutId xmlns:r="http://schemas.openxmlformats.org/officeDocument/2006/relationships" id="2147483654" r:id="R3e75312f3e394a95"/>
+    <p:sldLayoutId xmlns:r="http://schemas.openxmlformats.org/officeDocument/2006/relationships" id="2147483655" r:id="R1de71db8fed544c2"/>
+    <p:sldLayoutId xmlns:r="http://schemas.openxmlformats.org/officeDocument/2006/relationships" id="2147483656" r:id="Rc85b24cc694a452f"/>
+    <p:sldLayoutId xmlns:r="http://schemas.openxmlformats.org/officeDocument/2006/relationships" id="2147483657" r:id="R6d741feb5c6f4d43"/>
+    <p:sldLayoutId xmlns:r="http://schemas.openxmlformats.org/officeDocument/2006/relationships" id="2147483658" r:id="Rf062a4b4688c4196"/>
+    <p:sldLayoutId xmlns:r="http://schemas.openxmlformats.org/officeDocument/2006/relationships" id="2147483659" r:id="R7e3f05ecede44c03"/>
+    <p:sldLayoutId xmlns:r="http://schemas.openxmlformats.org/officeDocument/2006/relationships" id="2147483660" r:id="R13bc6d9f72514253"/>
+    <p:sldLayoutId xmlns:r="http://schemas.openxmlformats.org/officeDocument/2006/relationships" id="2147483661" r:id="Rf96ffbb35b7343f8"/>
   </p:sldLayoutIdLst>
   <p:txStyles>
     <p:titleStyle>
@@ -4308,7 +4308,7 @@
           <p:nvPr/>
         </p:nvPicPr>
         <p:blipFill>
-          <a:blip xmlns:r="http://schemas.openxmlformats.org/officeDocument/2006/relationships" xmlns:a="http://schemas.openxmlformats.org/drawingml/2006/main" r:embed="R976e1b344f7a418d"/>
+          <a:blip xmlns:r="http://schemas.openxmlformats.org/officeDocument/2006/relationships" xmlns:a="http://schemas.openxmlformats.org/drawingml/2006/main" r:embed="R9c2a82e7e7bc4524"/>
           <a:srcRect xmlns:a="http://schemas.openxmlformats.org/drawingml/2006/main" l="0" t="0" r="0" b="0"/>
           <a:stretch xmlns:a="http://schemas.openxmlformats.org/drawingml/2006/main"/>
         </p:blipFill>
@@ -4377,7 +4377,7 @@
                 <a:ea typeface="Lato"/>
                 <a:cs typeface="Lato"/>
               </a:rPr>
-              <a:t>A machine learning model to determine the accuracy of variant calls in capture based next generation sequencing</a:t>
+              <a:t>Capture NGS Variant Confidence Classifier</a:t>
             </a:r>
           </a:p>
         </p:txBody>
@@ -4387,7 +4387,7 @@
           <p:cNvPr id="13" name="explicit white background">
             <a:extLst xmlns:a="http://schemas.openxmlformats.org/drawingml/2006/main">
               <a:ext uri="{FF2B5EF4-FFF2-40B4-BE49-F238E27FC236}">
-                <a16:creationId xmlns:a16="http://schemas.microsoft.com/office/drawing/2014/main" id="{CD7AC66D-3F01-4959-8880-E229124C4985}"/>
+                <a16:creationId xmlns:a16="http://schemas.microsoft.com/office/drawing/2014/main" id="{B2809AEF-B5AF-4851-B480-E8D8A1FE9E2E}"/>
               </a:ext>
             </a:extLst>
           </p:cNvPr>
@@ -4420,7 +4420,7 @@
           <p:cNvPr id="14" name="">
             <a:extLst xmlns:a="http://schemas.openxmlformats.org/drawingml/2006/main">
               <a:ext uri="{FF2B5EF4-FFF2-40B4-BE49-F238E27FC236}">
-                <a16:creationId xmlns:a16="http://schemas.microsoft.com/office/drawing/2014/main" id="{C83962C0-B567-4578-8C07-33B10906759E}"/>
+                <a16:creationId xmlns:a16="http://schemas.microsoft.com/office/drawing/2014/main" id="{A8A486C3-6F80-4F82-866F-7F8882619F5D}"/>
               </a:ext>
             </a:extLst>
           </p:cNvPr>
@@ -4453,7 +4453,7 @@
           <p:cNvPr id="15" name="">
             <a:extLst xmlns:a="http://schemas.openxmlformats.org/drawingml/2006/main">
               <a:ext uri="{FF2B5EF4-FFF2-40B4-BE49-F238E27FC236}">
-                <a16:creationId xmlns:a16="http://schemas.microsoft.com/office/drawing/2014/main" id="{6BD10570-CCDC-42AD-83AB-3D66F8D2E916}"/>
+                <a16:creationId xmlns:a16="http://schemas.microsoft.com/office/drawing/2014/main" id="{2AA525FE-BA9F-4FFF-BFF4-A2D48BA881C4}"/>
               </a:ext>
             </a:extLst>
           </p:cNvPr>
@@ -4486,7 +4486,7 @@
           <p:cNvPr id="16" name="">
             <a:extLst xmlns:a="http://schemas.openxmlformats.org/drawingml/2006/main">
               <a:ext uri="{FF2B5EF4-FFF2-40B4-BE49-F238E27FC236}">
-                <a16:creationId xmlns:a16="http://schemas.microsoft.com/office/drawing/2014/main" id="{20644E58-2767-439F-82D9-3DDAEC7F5D47}"/>
+                <a16:creationId xmlns:a16="http://schemas.microsoft.com/office/drawing/2014/main" id="{20DEA854-2956-4AC7-BC96-2CAB61E033DE}"/>
               </a:ext>
             </a:extLst>
           </p:cNvPr>
@@ -4519,7 +4519,7 @@
           <p:cNvPr id="17" name="">
             <a:extLst xmlns:a="http://schemas.openxmlformats.org/drawingml/2006/main">
               <a:ext uri="{FF2B5EF4-FFF2-40B4-BE49-F238E27FC236}">
-                <a16:creationId xmlns:a16="http://schemas.microsoft.com/office/drawing/2014/main" id="{3077B7A7-B363-4CDE-9E37-131C9CC9C251}"/>
+                <a16:creationId xmlns:a16="http://schemas.microsoft.com/office/drawing/2014/main" id="{4D2BBC98-0268-4BF8-8FE5-5AAFBAC5246D}"/>
               </a:ext>
             </a:extLst>
           </p:cNvPr>
@@ -4573,7 +4573,7 @@
                 <a:ea typeface="Calibri"/>
                 <a:cs typeface="Calibri"/>
               </a:rPr>
-              <a:t>Logistic Regression cho đánh giá độ tin cậy variant call</a:t>
+              <a:t>Dự án cá nhân: Logistic Regression cho đánh giá độ tin cậy variant call</a:t>
             </a:r>
           </a:p>
           <a:p xmlns:a="http://schemas.openxmlformats.org/drawingml/2006/main">
@@ -4596,7 +4596,7 @@
                 <a:ea typeface="Calibri"/>
                 <a:cs typeface="Calibri"/>
               </a:rPr>
-              <a:t>BMC Genomics 2018 | Dữ liệu: Supplementary Table S2 | Mục tiêu: mô hình bảo thủ, FP = 0</a:t>
+              <a:t>Dữ liệu public variant-level | Mục tiêu: mô hình bảo thủ, FP = 0</a:t>
             </a:r>
           </a:p>
         </p:txBody>
@@ -4606,7 +4606,7 @@
           <p:cNvPr id="18" name="">
             <a:extLst xmlns:a="http://schemas.openxmlformats.org/drawingml/2006/main">
               <a:ext uri="{FF2B5EF4-FFF2-40B4-BE49-F238E27FC236}">
-                <a16:creationId xmlns:a16="http://schemas.microsoft.com/office/drawing/2014/main" id="{01B4D7C6-149C-492F-B0D3-D6795C92E0E8}"/>
+                <a16:creationId xmlns:a16="http://schemas.microsoft.com/office/drawing/2014/main" id="{E572AAFE-24AB-431D-985C-0FAF9714EFF6}"/>
               </a:ext>
             </a:extLst>
           </p:cNvPr>
@@ -4639,7 +4639,7 @@
           <p:cNvPr id="19" name="">
             <a:extLst xmlns:a="http://schemas.openxmlformats.org/drawingml/2006/main">
               <a:ext uri="{FF2B5EF4-FFF2-40B4-BE49-F238E27FC236}">
-                <a16:creationId xmlns:a16="http://schemas.microsoft.com/office/drawing/2014/main" id="{CA97B027-3CD6-4671-B319-AB2DE5B3363B}"/>
+                <a16:creationId xmlns:a16="http://schemas.microsoft.com/office/drawing/2014/main" id="{0C9CC829-F33C-49F4-8BB7-7FA2254B5A69}"/>
               </a:ext>
             </a:extLst>
           </p:cNvPr>
@@ -4703,7 +4703,7 @@
           <p:cNvPr id="20" name="">
             <a:extLst xmlns:a="http://schemas.openxmlformats.org/drawingml/2006/main">
               <a:ext uri="{FF2B5EF4-FFF2-40B4-BE49-F238E27FC236}">
-                <a16:creationId xmlns:a16="http://schemas.microsoft.com/office/drawing/2014/main" id="{D72EE65C-8AA0-42E1-A414-C7CD75DA712C}"/>
+                <a16:creationId xmlns:a16="http://schemas.microsoft.com/office/drawing/2014/main" id="{9DF95A26-AB4B-461D-91FC-981605BAF6D5}"/>
               </a:ext>
             </a:extLst>
           </p:cNvPr>
@@ -4757,7 +4757,7 @@
                 <a:ea typeface="Calibri"/>
                 <a:cs typeface="Calibri"/>
               </a:rPr>
-              <a:t>variants trong bài báo</a:t>
+              <a:t>variants trong dataset</a:t>
             </a:r>
           </a:p>
         </p:txBody>
@@ -4767,7 +4767,7 @@
           <p:cNvPr id="21" name="">
             <a:extLst xmlns:a="http://schemas.openxmlformats.org/drawingml/2006/main">
               <a:ext uri="{FF2B5EF4-FFF2-40B4-BE49-F238E27FC236}">
-                <a16:creationId xmlns:a16="http://schemas.microsoft.com/office/drawing/2014/main" id="{A915102D-029C-4758-9244-E1B49E5FF5BD}"/>
+                <a16:creationId xmlns:a16="http://schemas.microsoft.com/office/drawing/2014/main" id="{A0D92FD3-98A5-4E35-AF86-F4A779786B06}"/>
               </a:ext>
             </a:extLst>
           </p:cNvPr>
@@ -4800,7 +4800,7 @@
           <p:cNvPr id="22" name="">
             <a:extLst xmlns:a="http://schemas.openxmlformats.org/drawingml/2006/main">
               <a:ext uri="{FF2B5EF4-FFF2-40B4-BE49-F238E27FC236}">
-                <a16:creationId xmlns:a16="http://schemas.microsoft.com/office/drawing/2014/main" id="{F861C382-8049-4EA9-AF8D-AF6A3C1B3951}"/>
+                <a16:creationId xmlns:a16="http://schemas.microsoft.com/office/drawing/2014/main" id="{CA7B80D1-87DA-48A0-BA0D-F4FDFED092EA}"/>
               </a:ext>
             </a:extLst>
           </p:cNvPr>
@@ -4864,7 +4864,7 @@
           <p:cNvPr id="23" name="">
             <a:extLst xmlns:a="http://schemas.openxmlformats.org/drawingml/2006/main">
               <a:ext uri="{FF2B5EF4-FFF2-40B4-BE49-F238E27FC236}">
-                <a16:creationId xmlns:a16="http://schemas.microsoft.com/office/drawing/2014/main" id="{FB35BE44-DAF4-4678-9CCE-79CFD95FC5D8}"/>
+                <a16:creationId xmlns:a16="http://schemas.microsoft.com/office/drawing/2014/main" id="{DBC5507D-A1B9-49AA-9DD5-C765F1A359D2}"/>
               </a:ext>
             </a:extLst>
           </p:cNvPr>
@@ -4928,7 +4928,7 @@
           <p:cNvPr id="24" name="">
             <a:extLst xmlns:a="http://schemas.openxmlformats.org/drawingml/2006/main">
               <a:ext uri="{FF2B5EF4-FFF2-40B4-BE49-F238E27FC236}">
-                <a16:creationId xmlns:a16="http://schemas.microsoft.com/office/drawing/2014/main" id="{AAB4E713-26B8-4B61-BD08-3F818B09A880}"/>
+                <a16:creationId xmlns:a16="http://schemas.microsoft.com/office/drawing/2014/main" id="{AF0334C9-FA00-4C53-A5E8-F006EAF16E76}"/>
               </a:ext>
             </a:extLst>
           </p:cNvPr>
@@ -4961,7 +4961,7 @@
           <p:cNvPr id="25" name="">
             <a:extLst xmlns:a="http://schemas.openxmlformats.org/drawingml/2006/main">
               <a:ext uri="{FF2B5EF4-FFF2-40B4-BE49-F238E27FC236}">
-                <a16:creationId xmlns:a16="http://schemas.microsoft.com/office/drawing/2014/main" id="{5A59FC42-1B02-486F-A8DA-D4C51D03746B}"/>
+                <a16:creationId xmlns:a16="http://schemas.microsoft.com/office/drawing/2014/main" id="{A1726463-0A85-4796-904B-5278684384D3}"/>
               </a:ext>
             </a:extLst>
           </p:cNvPr>
@@ -5025,7 +5025,7 @@
           <p:cNvPr id="26" name="">
             <a:extLst xmlns:a="http://schemas.openxmlformats.org/drawingml/2006/main">
               <a:ext uri="{FF2B5EF4-FFF2-40B4-BE49-F238E27FC236}">
-                <a16:creationId xmlns:a16="http://schemas.microsoft.com/office/drawing/2014/main" id="{043912F9-8254-4401-946C-768E86F6D4A7}"/>
+                <a16:creationId xmlns:a16="http://schemas.microsoft.com/office/drawing/2014/main" id="{F5731577-8E1A-4DDF-8FC1-263EEF2A7A66}"/>
               </a:ext>
             </a:extLst>
           </p:cNvPr>
@@ -5089,7 +5089,7 @@
           <p:cNvPr id="27" name="">
             <a:extLst xmlns:a="http://schemas.openxmlformats.org/drawingml/2006/main">
               <a:ext uri="{FF2B5EF4-FFF2-40B4-BE49-F238E27FC236}">
-                <a16:creationId xmlns:a16="http://schemas.microsoft.com/office/drawing/2014/main" id="{14194A8E-CC8C-4A90-93F1-E095A59C0376}"/>
+                <a16:creationId xmlns:a16="http://schemas.microsoft.com/office/drawing/2014/main" id="{CEC8D931-915B-46EB-A6F6-329BB2FC8927}"/>
               </a:ext>
             </a:extLst>
           </p:cNvPr>
@@ -5122,7 +5122,7 @@
           <p:cNvPr id="28" name="">
             <a:extLst xmlns:a="http://schemas.openxmlformats.org/drawingml/2006/main">
               <a:ext uri="{FF2B5EF4-FFF2-40B4-BE49-F238E27FC236}">
-                <a16:creationId xmlns:a16="http://schemas.microsoft.com/office/drawing/2014/main" id="{4FF243FB-BDF4-4834-AF14-5A69FB0CDEBB}"/>
+                <a16:creationId xmlns:a16="http://schemas.microsoft.com/office/drawing/2014/main" id="{99238733-7D88-44AD-9350-760AEAFB321C}"/>
               </a:ext>
             </a:extLst>
           </p:cNvPr>
@@ -5186,7 +5186,7 @@
           <p:cNvPr id="29" name="">
             <a:extLst xmlns:a="http://schemas.openxmlformats.org/drawingml/2006/main">
               <a:ext uri="{FF2B5EF4-FFF2-40B4-BE49-F238E27FC236}">
-                <a16:creationId xmlns:a16="http://schemas.microsoft.com/office/drawing/2014/main" id="{FCB34002-64C4-45DC-BE1B-C3D937B118DF}"/>
+                <a16:creationId xmlns:a16="http://schemas.microsoft.com/office/drawing/2014/main" id="{714A59A8-7B40-4DF8-98D6-99B84EEEE2B8}"/>
               </a:ext>
             </a:extLst>
           </p:cNvPr>
@@ -5250,7 +5250,7 @@
           <p:cNvPr id="30" name="">
             <a:extLst xmlns:a="http://schemas.openxmlformats.org/drawingml/2006/main">
               <a:ext uri="{FF2B5EF4-FFF2-40B4-BE49-F238E27FC236}">
-                <a16:creationId xmlns:a16="http://schemas.microsoft.com/office/drawing/2014/main" id="{6EE1852D-9C94-47E1-8CB7-2BF8B6DA9045}"/>
+                <a16:creationId xmlns:a16="http://schemas.microsoft.com/office/drawing/2014/main" id="{1DCFFCEA-8EAC-4A32-8895-CEF19AD25987}"/>
               </a:ext>
             </a:extLst>
           </p:cNvPr>
@@ -5304,7 +5304,7 @@
                 <a:ea typeface="Calibri"/>
                 <a:cs typeface="Calibri"/>
               </a:rPr>
-              <a:t>Nguồn: van den Akker et al., BMC Genomics 2018; PMID 29665779; Supplementary Table S2</a:t>
+              <a:t>Nguồn dữ liệu: public variant-level Excel dataset</a:t>
             </a:r>
           </a:p>
         </p:txBody>
@@ -5410,7 +5410,7 @@
           <p:cNvPr id="4" name="explicit white background">
             <a:extLst xmlns:a="http://schemas.openxmlformats.org/drawingml/2006/main">
               <a:ext uri="{FF2B5EF4-FFF2-40B4-BE49-F238E27FC236}">
-                <a16:creationId xmlns:a16="http://schemas.microsoft.com/office/drawing/2014/main" id="{6C5302B4-B530-4A08-9D84-40A5D60763F9}"/>
+                <a16:creationId xmlns:a16="http://schemas.microsoft.com/office/drawing/2014/main" id="{66ADCB91-6CB8-406B-8EDA-6C4CC4062C82}"/>
               </a:ext>
             </a:extLst>
           </p:cNvPr>
@@ -5443,7 +5443,7 @@
           <p:cNvPr id="5" name="">
             <a:extLst xmlns:a="http://schemas.openxmlformats.org/drawingml/2006/main">
               <a:ext uri="{FF2B5EF4-FFF2-40B4-BE49-F238E27FC236}">
-                <a16:creationId xmlns:a16="http://schemas.microsoft.com/office/drawing/2014/main" id="{6653F17F-AE02-446C-B27A-3922B94E63D8}"/>
+                <a16:creationId xmlns:a16="http://schemas.microsoft.com/office/drawing/2014/main" id="{061880FD-C920-43ED-938F-594B052C2DD7}"/>
               </a:ext>
             </a:extLst>
           </p:cNvPr>
@@ -5476,7 +5476,7 @@
           <p:cNvPr id="6" name="">
             <a:extLst xmlns:a="http://schemas.openxmlformats.org/drawingml/2006/main">
               <a:ext uri="{FF2B5EF4-FFF2-40B4-BE49-F238E27FC236}">
-                <a16:creationId xmlns:a16="http://schemas.microsoft.com/office/drawing/2014/main" id="{8C252E3E-CBB4-4553-A4F8-881548970A80}"/>
+                <a16:creationId xmlns:a16="http://schemas.microsoft.com/office/drawing/2014/main" id="{B0678F7D-E2B1-4B80-9D8F-A708D0E2A956}"/>
               </a:ext>
             </a:extLst>
           </p:cNvPr>
@@ -5540,7 +5540,7 @@
           <p:cNvPr id="7" name="">
             <a:extLst xmlns:a="http://schemas.openxmlformats.org/drawingml/2006/main">
               <a:ext uri="{FF2B5EF4-FFF2-40B4-BE49-F238E27FC236}">
-                <a16:creationId xmlns:a16="http://schemas.microsoft.com/office/drawing/2014/main" id="{3549BC62-C3C4-4B4B-B44D-4395B28A3CC8}"/>
+                <a16:creationId xmlns:a16="http://schemas.microsoft.com/office/drawing/2014/main" id="{BD84DBF0-CEEA-4301-9910-16B8B710577E}"/>
               </a:ext>
             </a:extLst>
           </p:cNvPr>
@@ -5573,7 +5573,7 @@
           <p:cNvPr id="8" name="">
             <a:extLst xmlns:a="http://schemas.openxmlformats.org/drawingml/2006/main">
               <a:ext uri="{FF2B5EF4-FFF2-40B4-BE49-F238E27FC236}">
-                <a16:creationId xmlns:a16="http://schemas.microsoft.com/office/drawing/2014/main" id="{99ACA579-B23E-4E5B-9A81-069AB11D7B40}"/>
+                <a16:creationId xmlns:a16="http://schemas.microsoft.com/office/drawing/2014/main" id="{72149315-A08C-4458-A040-525A83DF932D}"/>
               </a:ext>
             </a:extLst>
           </p:cNvPr>
@@ -5726,7 +5726,7 @@
           <p:cNvPr id="5" name="explicit white background">
             <a:extLst xmlns:a="http://schemas.openxmlformats.org/drawingml/2006/main">
               <a:ext uri="{FF2B5EF4-FFF2-40B4-BE49-F238E27FC236}">
-                <a16:creationId xmlns:a16="http://schemas.microsoft.com/office/drawing/2014/main" id="{AF7E93B2-7953-4FBA-869B-0686EF505313}"/>
+                <a16:creationId xmlns:a16="http://schemas.microsoft.com/office/drawing/2014/main" id="{006D2AD2-348E-4842-B709-B4BC26F53B73}"/>
               </a:ext>
             </a:extLst>
           </p:cNvPr>
@@ -5759,7 +5759,7 @@
           <p:cNvPr id="6" name="HUST red title bar">
             <a:extLst xmlns:a="http://schemas.openxmlformats.org/drawingml/2006/main">
               <a:ext uri="{FF2B5EF4-FFF2-40B4-BE49-F238E27FC236}">
-                <a16:creationId xmlns:a16="http://schemas.microsoft.com/office/drawing/2014/main" id="{FD12F4BF-1769-482C-9D51-3F207246375C}"/>
+                <a16:creationId xmlns:a16="http://schemas.microsoft.com/office/drawing/2014/main" id="{E2584F20-2A48-419F-A329-A0E3B1B5954B}"/>
               </a:ext>
             </a:extLst>
           </p:cNvPr>
@@ -5792,7 +5792,7 @@
           <p:cNvPr id="7" name="HUST gold divider">
             <a:extLst xmlns:a="http://schemas.openxmlformats.org/drawingml/2006/main">
               <a:ext uri="{FF2B5EF4-FFF2-40B4-BE49-F238E27FC236}">
-                <a16:creationId xmlns:a16="http://schemas.microsoft.com/office/drawing/2014/main" id="{81D7766E-B2FD-4F03-A220-FF207D8FB774}"/>
+                <a16:creationId xmlns:a16="http://schemas.microsoft.com/office/drawing/2014/main" id="{7D2E09F0-4242-48B7-8EDA-F0CFC987CD82}"/>
               </a:ext>
             </a:extLst>
           </p:cNvPr>
@@ -5825,7 +5825,7 @@
           <p:cNvPr id="8" name="">
             <a:extLst xmlns:a="http://schemas.openxmlformats.org/drawingml/2006/main">
               <a:ext uri="{FF2B5EF4-FFF2-40B4-BE49-F238E27FC236}">
-                <a16:creationId xmlns:a16="http://schemas.microsoft.com/office/drawing/2014/main" id="{8D4F4885-D846-470D-AF89-FD0BAF3A5CC5}"/>
+                <a16:creationId xmlns:a16="http://schemas.microsoft.com/office/drawing/2014/main" id="{493170B3-486D-4451-BC35-6AF64966C00E}"/>
               </a:ext>
             </a:extLst>
           </p:cNvPr>
@@ -5889,7 +5889,7 @@
           <p:cNvPr id="9" name="">
             <a:extLst xmlns:a="http://schemas.openxmlformats.org/drawingml/2006/main">
               <a:ext uri="{FF2B5EF4-FFF2-40B4-BE49-F238E27FC236}">
-                <a16:creationId xmlns:a16="http://schemas.microsoft.com/office/drawing/2014/main" id="{C1C736C4-48AF-4E7C-820A-432BC207834F}"/>
+                <a16:creationId xmlns:a16="http://schemas.microsoft.com/office/drawing/2014/main" id="{1FA85E22-F60A-44D1-8583-5D1171729492}"/>
               </a:ext>
             </a:extLst>
           </p:cNvPr>
@@ -5922,7 +5922,7 @@
           <p:cNvPr id="10" name="">
             <a:extLst xmlns:a="http://schemas.openxmlformats.org/drawingml/2006/main">
               <a:ext uri="{FF2B5EF4-FFF2-40B4-BE49-F238E27FC236}">
-                <a16:creationId xmlns:a16="http://schemas.microsoft.com/office/drawing/2014/main" id="{4C5D9997-4F58-4685-A0DE-CEF33B3FA2DE}"/>
+                <a16:creationId xmlns:a16="http://schemas.microsoft.com/office/drawing/2014/main" id="{FD05342E-C370-472B-94DA-0FD7A6F4E253}"/>
               </a:ext>
             </a:extLst>
           </p:cNvPr>
@@ -5955,7 +5955,7 @@
           <p:cNvPr id="11" name="">
             <a:extLst xmlns:a="http://schemas.openxmlformats.org/drawingml/2006/main">
               <a:ext uri="{FF2B5EF4-FFF2-40B4-BE49-F238E27FC236}">
-                <a16:creationId xmlns:a16="http://schemas.microsoft.com/office/drawing/2014/main" id="{C7173B0C-E68C-442F-A60E-5865CDEA477C}"/>
+                <a16:creationId xmlns:a16="http://schemas.microsoft.com/office/drawing/2014/main" id="{3ACB4168-C9B7-4CCC-8DCE-06E1FF84E396}"/>
               </a:ext>
             </a:extLst>
           </p:cNvPr>
@@ -6019,7 +6019,7 @@
           <p:cNvPr id="12" name="">
             <a:extLst xmlns:a="http://schemas.openxmlformats.org/drawingml/2006/main">
               <a:ext uri="{FF2B5EF4-FFF2-40B4-BE49-F238E27FC236}">
-                <a16:creationId xmlns:a16="http://schemas.microsoft.com/office/drawing/2014/main" id="{F26A0011-4C13-447B-980F-5F9C763D7244}"/>
+                <a16:creationId xmlns:a16="http://schemas.microsoft.com/office/drawing/2014/main" id="{6188B399-C852-430D-84E3-8C771010BBDE}"/>
               </a:ext>
             </a:extLst>
           </p:cNvPr>
@@ -6129,7 +6129,7 @@
           <p:cNvPr id="13" name="">
             <a:extLst xmlns:a="http://schemas.openxmlformats.org/drawingml/2006/main">
               <a:ext uri="{FF2B5EF4-FFF2-40B4-BE49-F238E27FC236}">
-                <a16:creationId xmlns:a16="http://schemas.microsoft.com/office/drawing/2014/main" id="{5FDB521F-28ED-42DE-8008-3B9CF08F8851}"/>
+                <a16:creationId xmlns:a16="http://schemas.microsoft.com/office/drawing/2014/main" id="{782FCA4E-D631-47FD-A9B3-65E96A4A4CFE}"/>
               </a:ext>
             </a:extLst>
           </p:cNvPr>
@@ -6162,7 +6162,7 @@
           <p:cNvPr id="14" name="">
             <a:extLst xmlns:a="http://schemas.openxmlformats.org/drawingml/2006/main">
               <a:ext uri="{FF2B5EF4-FFF2-40B4-BE49-F238E27FC236}">
-                <a16:creationId xmlns:a16="http://schemas.microsoft.com/office/drawing/2014/main" id="{6FBDFFF4-DD74-4C66-9914-B32B3998205B}"/>
+                <a16:creationId xmlns:a16="http://schemas.microsoft.com/office/drawing/2014/main" id="{BC3EE4ED-8E2E-41FA-BA20-35030CCF1418}"/>
               </a:ext>
             </a:extLst>
           </p:cNvPr>
@@ -6216,7 +6216,7 @@
                 <a:ea typeface="Lato"/>
                 <a:cs typeface="Lato"/>
               </a:rPr>
-              <a:t>Mục tiêu của bài báo</a:t>
+              <a:t>Mục tiêu của dự án</a:t>
             </a:r>
           </a:p>
         </p:txBody>
@@ -6226,7 +6226,7 @@
           <p:cNvPr id="15" name="">
             <a:extLst xmlns:a="http://schemas.openxmlformats.org/drawingml/2006/main">
               <a:ext uri="{FF2B5EF4-FFF2-40B4-BE49-F238E27FC236}">
-                <a16:creationId xmlns:a16="http://schemas.microsoft.com/office/drawing/2014/main" id="{339B3BD5-FDDD-4162-A23E-8C39597FF35D}"/>
+                <a16:creationId xmlns:a16="http://schemas.microsoft.com/office/drawing/2014/main" id="{BF045622-6B93-440E-8786-033E97ADCB1D}"/>
               </a:ext>
             </a:extLst>
           </p:cNvPr>
@@ -6359,7 +6359,7 @@
           <p:cNvPr id="16" name="">
             <a:extLst xmlns:a="http://schemas.openxmlformats.org/drawingml/2006/main">
               <a:ext uri="{FF2B5EF4-FFF2-40B4-BE49-F238E27FC236}">
-                <a16:creationId xmlns:a16="http://schemas.microsoft.com/office/drawing/2014/main" id="{1D728E67-EB73-47C6-A745-4A702EAB00DB}"/>
+                <a16:creationId xmlns:a16="http://schemas.microsoft.com/office/drawing/2014/main" id="{64FED429-DCFD-4827-BE5A-55CACA6A0EB9}"/>
               </a:ext>
             </a:extLst>
           </p:cNvPr>
@@ -6392,7 +6392,7 @@
           <p:cNvPr id="17" name="">
             <a:extLst xmlns:a="http://schemas.openxmlformats.org/drawingml/2006/main">
               <a:ext uri="{FF2B5EF4-FFF2-40B4-BE49-F238E27FC236}">
-                <a16:creationId xmlns:a16="http://schemas.microsoft.com/office/drawing/2014/main" id="{1C945130-7168-4D9A-82EE-13C41FBCC1E9}"/>
+                <a16:creationId xmlns:a16="http://schemas.microsoft.com/office/drawing/2014/main" id="{971C6FCE-E668-41F6-B0C3-A0ABC79B0931}"/>
               </a:ext>
             </a:extLst>
           </p:cNvPr>
@@ -6514,7 +6514,7 @@
           <p:cNvPr id="5" name="explicit white background">
             <a:extLst xmlns:a="http://schemas.openxmlformats.org/drawingml/2006/main">
               <a:ext uri="{FF2B5EF4-FFF2-40B4-BE49-F238E27FC236}">
-                <a16:creationId xmlns:a16="http://schemas.microsoft.com/office/drawing/2014/main" id="{2473E2B3-52D1-4AC3-9F63-1E1AAC9FA49A}"/>
+                <a16:creationId xmlns:a16="http://schemas.microsoft.com/office/drawing/2014/main" id="{8117226A-49D1-4EA2-8DCB-60FA48FCB388}"/>
               </a:ext>
             </a:extLst>
           </p:cNvPr>
@@ -6547,7 +6547,7 @@
           <p:cNvPr id="6" name="HUST red title bar">
             <a:extLst xmlns:a="http://schemas.openxmlformats.org/drawingml/2006/main">
               <a:ext uri="{FF2B5EF4-FFF2-40B4-BE49-F238E27FC236}">
-                <a16:creationId xmlns:a16="http://schemas.microsoft.com/office/drawing/2014/main" id="{6E5B1478-0C3F-4C41-AC81-92B4AEC14F21}"/>
+                <a16:creationId xmlns:a16="http://schemas.microsoft.com/office/drawing/2014/main" id="{302E1A26-A150-49F8-82F6-CC9AD737D797}"/>
               </a:ext>
             </a:extLst>
           </p:cNvPr>
@@ -6580,7 +6580,7 @@
           <p:cNvPr id="7" name="HUST gold divider">
             <a:extLst xmlns:a="http://schemas.openxmlformats.org/drawingml/2006/main">
               <a:ext uri="{FF2B5EF4-FFF2-40B4-BE49-F238E27FC236}">
-                <a16:creationId xmlns:a16="http://schemas.microsoft.com/office/drawing/2014/main" id="{62800BD8-B716-444C-893A-22E62BCE6AC5}"/>
+                <a16:creationId xmlns:a16="http://schemas.microsoft.com/office/drawing/2014/main" id="{D4ED5AA4-2930-41CB-AF82-83D406A8FE95}"/>
               </a:ext>
             </a:extLst>
           </p:cNvPr>
@@ -6613,7 +6613,7 @@
           <p:cNvPr id="8" name="">
             <a:extLst xmlns:a="http://schemas.openxmlformats.org/drawingml/2006/main">
               <a:ext uri="{FF2B5EF4-FFF2-40B4-BE49-F238E27FC236}">
-                <a16:creationId xmlns:a16="http://schemas.microsoft.com/office/drawing/2014/main" id="{564BEBB7-0FB9-423A-988C-6B2183D430EE}"/>
+                <a16:creationId xmlns:a16="http://schemas.microsoft.com/office/drawing/2014/main" id="{2C9D0FF5-469D-4C7F-AA36-0EE52EE825A2}"/>
               </a:ext>
             </a:extLst>
           </p:cNvPr>
@@ -6677,7 +6677,7 @@
           <p:cNvPr id="9" name="">
             <a:extLst xmlns:a="http://schemas.openxmlformats.org/drawingml/2006/main">
               <a:ext uri="{FF2B5EF4-FFF2-40B4-BE49-F238E27FC236}">
-                <a16:creationId xmlns:a16="http://schemas.microsoft.com/office/drawing/2014/main" id="{74F0DB6C-0BA4-4EDA-8EA2-BCD6617DA1AA}"/>
+                <a16:creationId xmlns:a16="http://schemas.microsoft.com/office/drawing/2014/main" id="{879514AC-B139-4E8E-8F43-12BFC94AE304}"/>
               </a:ext>
             </a:extLst>
           </p:cNvPr>
@@ -6710,7 +6710,7 @@
           <p:cNvPr id="10" name="">
             <a:extLst xmlns:a="http://schemas.openxmlformats.org/drawingml/2006/main">
               <a:ext uri="{FF2B5EF4-FFF2-40B4-BE49-F238E27FC236}">
-                <a16:creationId xmlns:a16="http://schemas.microsoft.com/office/drawing/2014/main" id="{810AF25B-520D-4815-991F-504A2C12E56B}"/>
+                <a16:creationId xmlns:a16="http://schemas.microsoft.com/office/drawing/2014/main" id="{118DA5B0-C092-4185-9E81-97A5C790239F}"/>
               </a:ext>
             </a:extLst>
           </p:cNvPr>
@@ -6743,7 +6743,7 @@
           <p:cNvPr id="11" name="">
             <a:extLst xmlns:a="http://schemas.openxmlformats.org/drawingml/2006/main">
               <a:ext uri="{FF2B5EF4-FFF2-40B4-BE49-F238E27FC236}">
-                <a16:creationId xmlns:a16="http://schemas.microsoft.com/office/drawing/2014/main" id="{B7071442-6AE6-4ABA-AFF8-46111426F791}"/>
+                <a16:creationId xmlns:a16="http://schemas.microsoft.com/office/drawing/2014/main" id="{4BBCBDD3-25B8-4621-98F2-116F139B8AAA}"/>
               </a:ext>
             </a:extLst>
           </p:cNvPr>
@@ -6807,7 +6807,7 @@
           <p:cNvPr id="12" name="">
             <a:extLst xmlns:a="http://schemas.openxmlformats.org/drawingml/2006/main">
               <a:ext uri="{FF2B5EF4-FFF2-40B4-BE49-F238E27FC236}">
-                <a16:creationId xmlns:a16="http://schemas.microsoft.com/office/drawing/2014/main" id="{03A91865-EA12-46CF-874F-4599DFC12EB5}"/>
+                <a16:creationId xmlns:a16="http://schemas.microsoft.com/office/drawing/2014/main" id="{766627D1-5F70-492C-84EF-F18BF0454E13}"/>
               </a:ext>
             </a:extLst>
           </p:cNvPr>
@@ -6871,7 +6871,7 @@
           <p:cNvPr id="13" name="">
             <a:extLst xmlns:a="http://schemas.openxmlformats.org/drawingml/2006/main">
               <a:ext uri="{FF2B5EF4-FFF2-40B4-BE49-F238E27FC236}">
-                <a16:creationId xmlns:a16="http://schemas.microsoft.com/office/drawing/2014/main" id="{38D5DDD4-6000-4067-8332-C9506E74A5F1}"/>
+                <a16:creationId xmlns:a16="http://schemas.microsoft.com/office/drawing/2014/main" id="{2CC3448A-CCCD-45A9-A03C-3EC704BB6E96}"/>
               </a:ext>
             </a:extLst>
           </p:cNvPr>
@@ -6904,7 +6904,7 @@
           <p:cNvPr id="14" name="">
             <a:extLst xmlns:a="http://schemas.openxmlformats.org/drawingml/2006/main">
               <a:ext uri="{FF2B5EF4-FFF2-40B4-BE49-F238E27FC236}">
-                <a16:creationId xmlns:a16="http://schemas.microsoft.com/office/drawing/2014/main" id="{660C84BA-6E07-4D26-997E-E7A75B9E4F73}"/>
+                <a16:creationId xmlns:a16="http://schemas.microsoft.com/office/drawing/2014/main" id="{3B512C4F-DE51-4D81-88B3-185363131846}"/>
               </a:ext>
             </a:extLst>
           </p:cNvPr>
@@ -6968,7 +6968,7 @@
           <p:cNvPr id="15" name="">
             <a:extLst xmlns:a="http://schemas.openxmlformats.org/drawingml/2006/main">
               <a:ext uri="{FF2B5EF4-FFF2-40B4-BE49-F238E27FC236}">
-                <a16:creationId xmlns:a16="http://schemas.microsoft.com/office/drawing/2014/main" id="{C2FCA00C-410A-4F7D-83BB-B91660639ECD}"/>
+                <a16:creationId xmlns:a16="http://schemas.microsoft.com/office/drawing/2014/main" id="{94E91458-CC7D-45FF-B337-A23715173EFD}"/>
               </a:ext>
             </a:extLst>
           </p:cNvPr>
@@ -7032,7 +7032,7 @@
           <p:cNvPr id="16" name="">
             <a:extLst xmlns:a="http://schemas.openxmlformats.org/drawingml/2006/main">
               <a:ext uri="{FF2B5EF4-FFF2-40B4-BE49-F238E27FC236}">
-                <a16:creationId xmlns:a16="http://schemas.microsoft.com/office/drawing/2014/main" id="{2683E8F2-A013-429F-80E4-274AEF573D52}"/>
+                <a16:creationId xmlns:a16="http://schemas.microsoft.com/office/drawing/2014/main" id="{D21951D6-9DB7-427D-8BD4-572CA373DC3A}"/>
               </a:ext>
             </a:extLst>
           </p:cNvPr>
@@ -7065,7 +7065,7 @@
           <p:cNvPr id="17" name="">
             <a:extLst xmlns:a="http://schemas.openxmlformats.org/drawingml/2006/main">
               <a:ext uri="{FF2B5EF4-FFF2-40B4-BE49-F238E27FC236}">
-                <a16:creationId xmlns:a16="http://schemas.microsoft.com/office/drawing/2014/main" id="{10A0156D-1EDD-425E-B692-A51A741FD2FF}"/>
+                <a16:creationId xmlns:a16="http://schemas.microsoft.com/office/drawing/2014/main" id="{AC630BED-A258-4659-B5CF-6EBE52E1FCAA}"/>
               </a:ext>
             </a:extLst>
           </p:cNvPr>
@@ -7129,7 +7129,7 @@
           <p:cNvPr id="18" name="">
             <a:extLst xmlns:a="http://schemas.openxmlformats.org/drawingml/2006/main">
               <a:ext uri="{FF2B5EF4-FFF2-40B4-BE49-F238E27FC236}">
-                <a16:creationId xmlns:a16="http://schemas.microsoft.com/office/drawing/2014/main" id="{5FDE5803-F47E-42AC-8848-092DBF9DB6DF}"/>
+                <a16:creationId xmlns:a16="http://schemas.microsoft.com/office/drawing/2014/main" id="{38CF91AB-6FF6-4FE5-9A5E-E6074A31B22D}"/>
               </a:ext>
             </a:extLst>
           </p:cNvPr>
@@ -7193,7 +7193,7 @@
           <p:cNvPr id="19" name="">
             <a:extLst xmlns:a="http://schemas.openxmlformats.org/drawingml/2006/main">
               <a:ext uri="{FF2B5EF4-FFF2-40B4-BE49-F238E27FC236}">
-                <a16:creationId xmlns:a16="http://schemas.microsoft.com/office/drawing/2014/main" id="{817F6F3C-BEF1-4A33-B4D9-DF9407415F0C}"/>
+                <a16:creationId xmlns:a16="http://schemas.microsoft.com/office/drawing/2014/main" id="{276129B8-9233-4310-A121-1044D6810594}"/>
               </a:ext>
             </a:extLst>
           </p:cNvPr>
@@ -7226,7 +7226,7 @@
           <p:cNvPr id="20" name="">
             <a:extLst xmlns:a="http://schemas.openxmlformats.org/drawingml/2006/main">
               <a:ext uri="{FF2B5EF4-FFF2-40B4-BE49-F238E27FC236}">
-                <a16:creationId xmlns:a16="http://schemas.microsoft.com/office/drawing/2014/main" id="{8918848B-8D89-4FDE-813F-5801F2B7D59A}"/>
+                <a16:creationId xmlns:a16="http://schemas.microsoft.com/office/drawing/2014/main" id="{FA49DE6D-6B35-4256-9A4C-23345261A23D}"/>
               </a:ext>
             </a:extLst>
           </p:cNvPr>
@@ -7280,7 +7280,7 @@
                 <a:ea typeface="Lato"/>
                 <a:cs typeface="Lato"/>
               </a:rPr>
-              <a:t>Table S2</a:t>
+              <a:t>Excel data</a:t>
             </a:r>
           </a:p>
         </p:txBody>
@@ -7290,7 +7290,7 @@
           <p:cNvPr id="21" name="">
             <a:extLst xmlns:a="http://schemas.openxmlformats.org/drawingml/2006/main">
               <a:ext uri="{FF2B5EF4-FFF2-40B4-BE49-F238E27FC236}">
-                <a16:creationId xmlns:a16="http://schemas.microsoft.com/office/drawing/2014/main" id="{AF0774C4-BE3B-4F26-B741-DB8185A157BD}"/>
+                <a16:creationId xmlns:a16="http://schemas.microsoft.com/office/drawing/2014/main" id="{AB4DBA13-DEFC-4705-9ACA-3596E698B5CF}"/>
               </a:ext>
             </a:extLst>
           </p:cNvPr>
@@ -7354,7 +7354,7 @@
           <p:cNvPr id="22" name="">
             <a:extLst xmlns:a="http://schemas.openxmlformats.org/drawingml/2006/main">
               <a:ext uri="{FF2B5EF4-FFF2-40B4-BE49-F238E27FC236}">
-                <a16:creationId xmlns:a16="http://schemas.microsoft.com/office/drawing/2014/main" id="{EF7AE214-8094-4AAA-8ED5-737305C393EB}"/>
+                <a16:creationId xmlns:a16="http://schemas.microsoft.com/office/drawing/2014/main" id="{A55607E0-8DB7-42AC-AE50-9DF609A55A3D}"/>
               </a:ext>
             </a:extLst>
           </p:cNvPr>
@@ -7387,7 +7387,7 @@
           <p:cNvPr id="23" name="">
             <a:extLst xmlns:a="http://schemas.openxmlformats.org/drawingml/2006/main">
               <a:ext uri="{FF2B5EF4-FFF2-40B4-BE49-F238E27FC236}">
-                <a16:creationId xmlns:a16="http://schemas.microsoft.com/office/drawing/2014/main" id="{6B50D6EA-BD98-411E-AC6A-48B78D5EC15A}"/>
+                <a16:creationId xmlns:a16="http://schemas.microsoft.com/office/drawing/2014/main" id="{326DBD0B-943A-4F03-BE73-DFBE63F18A9E}"/>
               </a:ext>
             </a:extLst>
           </p:cNvPr>
@@ -7451,7 +7451,7 @@
           <p:cNvPr id="24" name="">
             <a:extLst xmlns:a="http://schemas.openxmlformats.org/drawingml/2006/main">
               <a:ext uri="{FF2B5EF4-FFF2-40B4-BE49-F238E27FC236}">
-                <a16:creationId xmlns:a16="http://schemas.microsoft.com/office/drawing/2014/main" id="{6DD8B1E2-5F98-42FE-95AC-798CF9E5B96D}"/>
+                <a16:creationId xmlns:a16="http://schemas.microsoft.com/office/drawing/2014/main" id="{D5D7C20B-5983-4DB2-AC52-5346F1465D8F}"/>
               </a:ext>
             </a:extLst>
           </p:cNvPr>
@@ -7538,7 +7538,7 @@
           <p:cNvPr id="25" name="">
             <a:extLst xmlns:a="http://schemas.openxmlformats.org/drawingml/2006/main">
               <a:ext uri="{FF2B5EF4-FFF2-40B4-BE49-F238E27FC236}">
-                <a16:creationId xmlns:a16="http://schemas.microsoft.com/office/drawing/2014/main" id="{D3E8CD3B-D166-4992-8BE1-A29AC04B8CB3}"/>
+                <a16:creationId xmlns:a16="http://schemas.microsoft.com/office/drawing/2014/main" id="{113C5994-9D47-42B4-84DC-0FE7889342D5}"/>
               </a:ext>
             </a:extLst>
           </p:cNvPr>
@@ -7571,7 +7571,7 @@
           <p:cNvPr id="26" name="">
             <a:extLst xmlns:a="http://schemas.openxmlformats.org/drawingml/2006/main">
               <a:ext uri="{FF2B5EF4-FFF2-40B4-BE49-F238E27FC236}">
-                <a16:creationId xmlns:a16="http://schemas.microsoft.com/office/drawing/2014/main" id="{F649D3A2-63ED-4F79-9FFC-69D1A67E1697}"/>
+                <a16:creationId xmlns:a16="http://schemas.microsoft.com/office/drawing/2014/main" id="{305E6F7F-659A-4A6D-8EC7-7B32EB0ADEB5}"/>
               </a:ext>
             </a:extLst>
           </p:cNvPr>
@@ -7635,7 +7635,7 @@
           <p:cNvPr id="27" name="">
             <a:extLst xmlns:a="http://schemas.openxmlformats.org/drawingml/2006/main">
               <a:ext uri="{FF2B5EF4-FFF2-40B4-BE49-F238E27FC236}">
-                <a16:creationId xmlns:a16="http://schemas.microsoft.com/office/drawing/2014/main" id="{0C7DB8FD-015F-467F-8B71-284EFF6D09ED}"/>
+                <a16:creationId xmlns:a16="http://schemas.microsoft.com/office/drawing/2014/main" id="{D3B0A907-1CA2-4489-972F-80BF9A149DDB}"/>
               </a:ext>
             </a:extLst>
           </p:cNvPr>
@@ -7722,7 +7722,7 @@
           <p:cNvPr id="28" name="">
             <a:extLst xmlns:a="http://schemas.openxmlformats.org/drawingml/2006/main">
               <a:ext uri="{FF2B5EF4-FFF2-40B4-BE49-F238E27FC236}">
-                <a16:creationId xmlns:a16="http://schemas.microsoft.com/office/drawing/2014/main" id="{86541E1B-9D68-44E0-88B4-F47BE1C530C9}"/>
+                <a16:creationId xmlns:a16="http://schemas.microsoft.com/office/drawing/2014/main" id="{CA8F4763-31CF-4BA8-ABE0-3E680E40E742}"/>
               </a:ext>
             </a:extLst>
           </p:cNvPr>
@@ -7755,7 +7755,7 @@
           <p:cNvPr id="29" name="">
             <a:extLst xmlns:a="http://schemas.openxmlformats.org/drawingml/2006/main">
               <a:ext uri="{FF2B5EF4-FFF2-40B4-BE49-F238E27FC236}">
-                <a16:creationId xmlns:a16="http://schemas.microsoft.com/office/drawing/2014/main" id="{37566B36-E4A5-4C94-AEBB-494FB804CA92}"/>
+                <a16:creationId xmlns:a16="http://schemas.microsoft.com/office/drawing/2014/main" id="{E0EE9212-5649-4AFE-9D43-ABA128D423ED}"/>
               </a:ext>
             </a:extLst>
           </p:cNvPr>
@@ -7819,7 +7819,7 @@
           <p:cNvPr id="30" name="">
             <a:extLst xmlns:a="http://schemas.openxmlformats.org/drawingml/2006/main">
               <a:ext uri="{FF2B5EF4-FFF2-40B4-BE49-F238E27FC236}">
-                <a16:creationId xmlns:a16="http://schemas.microsoft.com/office/drawing/2014/main" id="{10144374-A37A-4B40-96BA-3CDB3F2BD28B}"/>
+                <a16:creationId xmlns:a16="http://schemas.microsoft.com/office/drawing/2014/main" id="{272D4B88-9DBE-41AE-8B64-16ECAF09E73D}"/>
               </a:ext>
             </a:extLst>
           </p:cNvPr>
@@ -7906,7 +7906,7 @@
           <p:cNvPr id="31" name="">
             <a:extLst xmlns:a="http://schemas.openxmlformats.org/drawingml/2006/main">
               <a:ext uri="{FF2B5EF4-FFF2-40B4-BE49-F238E27FC236}">
-                <a16:creationId xmlns:a16="http://schemas.microsoft.com/office/drawing/2014/main" id="{0CA8389C-0A25-45ED-8816-38BDAB75A7CF}"/>
+                <a16:creationId xmlns:a16="http://schemas.microsoft.com/office/drawing/2014/main" id="{55CC6178-DB91-430F-AD62-BB776B429CD9}"/>
               </a:ext>
             </a:extLst>
           </p:cNvPr>
@@ -7939,7 +7939,7 @@
           <p:cNvPr id="32" name="">
             <a:extLst xmlns:a="http://schemas.openxmlformats.org/drawingml/2006/main">
               <a:ext uri="{FF2B5EF4-FFF2-40B4-BE49-F238E27FC236}">
-                <a16:creationId xmlns:a16="http://schemas.microsoft.com/office/drawing/2014/main" id="{CAD13644-7CD9-4C08-86E8-777E23DACA1F}"/>
+                <a16:creationId xmlns:a16="http://schemas.microsoft.com/office/drawing/2014/main" id="{3469D6AB-B878-4441-AE8E-A7B6E02CFE4A}"/>
               </a:ext>
             </a:extLst>
           </p:cNvPr>
@@ -8003,7 +8003,7 @@
           <p:cNvPr id="33" name="">
             <a:extLst xmlns:a="http://schemas.openxmlformats.org/drawingml/2006/main">
               <a:ext uri="{FF2B5EF4-FFF2-40B4-BE49-F238E27FC236}">
-                <a16:creationId xmlns:a16="http://schemas.microsoft.com/office/drawing/2014/main" id="{F11ABCAD-5A02-4297-B406-B8F9B4BBC809}"/>
+                <a16:creationId xmlns:a16="http://schemas.microsoft.com/office/drawing/2014/main" id="{835E82BA-34D7-40EF-933E-FADCC21B412A}"/>
               </a:ext>
             </a:extLst>
           </p:cNvPr>
@@ -8090,7 +8090,7 @@
           <p:cNvPr id="34" name="">
             <a:extLst xmlns:a="http://schemas.openxmlformats.org/drawingml/2006/main">
               <a:ext uri="{FF2B5EF4-FFF2-40B4-BE49-F238E27FC236}">
-                <a16:creationId xmlns:a16="http://schemas.microsoft.com/office/drawing/2014/main" id="{C516CA7A-FBD4-41D4-B1BC-197E75565D5F}"/>
+                <a16:creationId xmlns:a16="http://schemas.microsoft.com/office/drawing/2014/main" id="{ACDF0A17-7299-4403-BA8D-D12C6FB8CD06}"/>
               </a:ext>
             </a:extLst>
           </p:cNvPr>
@@ -8123,7 +8123,7 @@
           <p:cNvPr id="35" name="">
             <a:extLst xmlns:a="http://schemas.openxmlformats.org/drawingml/2006/main">
               <a:ext uri="{FF2B5EF4-FFF2-40B4-BE49-F238E27FC236}">
-                <a16:creationId xmlns:a16="http://schemas.microsoft.com/office/drawing/2014/main" id="{DCA14F48-5C81-4C36-B444-20D279270816}"/>
+                <a16:creationId xmlns:a16="http://schemas.microsoft.com/office/drawing/2014/main" id="{E67555BA-62F6-411D-B71B-51FD2CEA496E}"/>
               </a:ext>
             </a:extLst>
           </p:cNvPr>
@@ -8187,7 +8187,7 @@
           <p:cNvPr id="36" name="">
             <a:extLst xmlns:a="http://schemas.openxmlformats.org/drawingml/2006/main">
               <a:ext uri="{FF2B5EF4-FFF2-40B4-BE49-F238E27FC236}">
-                <a16:creationId xmlns:a16="http://schemas.microsoft.com/office/drawing/2014/main" id="{FD11D76B-9F0C-4748-9598-88373019DFCE}"/>
+                <a16:creationId xmlns:a16="http://schemas.microsoft.com/office/drawing/2014/main" id="{7D57074C-9AC3-4AAD-8B19-1B4F5073AC17}"/>
               </a:ext>
             </a:extLst>
           </p:cNvPr>
@@ -8251,7 +8251,7 @@
           <p:cNvPr id="37" name="">
             <a:extLst xmlns:a="http://schemas.openxmlformats.org/drawingml/2006/main">
               <a:ext uri="{FF2B5EF4-FFF2-40B4-BE49-F238E27FC236}">
-                <a16:creationId xmlns:a16="http://schemas.microsoft.com/office/drawing/2014/main" id="{0A1BE1DA-2373-463A-A8A2-1365E20ADFF5}"/>
+                <a16:creationId xmlns:a16="http://schemas.microsoft.com/office/drawing/2014/main" id="{365826E1-2444-443F-9E81-7E62FBB8DE38}"/>
               </a:ext>
             </a:extLst>
           </p:cNvPr>
@@ -8305,7 +8305,7 @@
                 <a:ea typeface="Calibri"/>
                 <a:cs typeface="Calibri"/>
               </a:rPr>
-              <a:t>Nguồn: van den Akker et al., BMC Genomics 2018; PMID 29665779; Supplementary Table S2</a:t>
+              <a:t>Nguồn dữ liệu: public variant-level Excel dataset</a:t>
             </a:r>
           </a:p>
         </p:txBody>
@@ -8363,7 +8363,7 @@
                 <a:ea typeface="Lato"/>
                 <a:cs typeface="Lato"/>
               </a:rPr>
-              <a:t>Pipeline tái lập từ dữ liệu của bài báo</a:t>
+              <a:t>Pipeline xử lý dữ liệu và huấn luyện</a:t>
             </a:r>
           </a:p>
         </p:txBody>
@@ -8373,7 +8373,7 @@
           <p:cNvPr id="5" name="explicit white background">
             <a:extLst xmlns:a="http://schemas.openxmlformats.org/drawingml/2006/main">
               <a:ext uri="{FF2B5EF4-FFF2-40B4-BE49-F238E27FC236}">
-                <a16:creationId xmlns:a16="http://schemas.microsoft.com/office/drawing/2014/main" id="{AB35C582-E3E6-46AF-8822-F966054FA218}"/>
+                <a16:creationId xmlns:a16="http://schemas.microsoft.com/office/drawing/2014/main" id="{12C1F244-FB9C-4CE0-90C7-2D8FE8403E56}"/>
               </a:ext>
             </a:extLst>
           </p:cNvPr>
@@ -8406,7 +8406,7 @@
           <p:cNvPr id="6" name="HUST red title bar">
             <a:extLst xmlns:a="http://schemas.openxmlformats.org/drawingml/2006/main">
               <a:ext uri="{FF2B5EF4-FFF2-40B4-BE49-F238E27FC236}">
-                <a16:creationId xmlns:a16="http://schemas.microsoft.com/office/drawing/2014/main" id="{DE7A8200-113E-425B-86A5-41D351F9F937}"/>
+                <a16:creationId xmlns:a16="http://schemas.microsoft.com/office/drawing/2014/main" id="{BB1564DB-8489-42BE-9825-4B6990AC4E72}"/>
               </a:ext>
             </a:extLst>
           </p:cNvPr>
@@ -8439,7 +8439,7 @@
           <p:cNvPr id="7" name="HUST gold divider">
             <a:extLst xmlns:a="http://schemas.openxmlformats.org/drawingml/2006/main">
               <a:ext uri="{FF2B5EF4-FFF2-40B4-BE49-F238E27FC236}">
-                <a16:creationId xmlns:a16="http://schemas.microsoft.com/office/drawing/2014/main" id="{DEEEE5A6-7803-4325-8149-FAB0F08D9862}"/>
+                <a16:creationId xmlns:a16="http://schemas.microsoft.com/office/drawing/2014/main" id="{C76D941B-7376-4487-B1FF-247F255B7973}"/>
               </a:ext>
             </a:extLst>
           </p:cNvPr>
@@ -8472,7 +8472,7 @@
           <p:cNvPr id="8" name="">
             <a:extLst xmlns:a="http://schemas.openxmlformats.org/drawingml/2006/main">
               <a:ext uri="{FF2B5EF4-FFF2-40B4-BE49-F238E27FC236}">
-                <a16:creationId xmlns:a16="http://schemas.microsoft.com/office/drawing/2014/main" id="{C498C1A2-D59B-47F0-8A74-3AA1DFD7EDD1}"/>
+                <a16:creationId xmlns:a16="http://schemas.microsoft.com/office/drawing/2014/main" id="{42CC26AE-D804-413B-98C3-B9F9F3327B03}"/>
               </a:ext>
             </a:extLst>
           </p:cNvPr>
@@ -8536,7 +8536,7 @@
           <p:cNvPr id="9" name="">
             <a:extLst xmlns:a="http://schemas.openxmlformats.org/drawingml/2006/main">
               <a:ext uri="{FF2B5EF4-FFF2-40B4-BE49-F238E27FC236}">
-                <a16:creationId xmlns:a16="http://schemas.microsoft.com/office/drawing/2014/main" id="{0BFB6634-C326-4676-8B86-5C709801092B}"/>
+                <a16:creationId xmlns:a16="http://schemas.microsoft.com/office/drawing/2014/main" id="{15BEEE5E-BAC1-45AF-8D87-079022166E5F}"/>
               </a:ext>
             </a:extLst>
           </p:cNvPr>
@@ -8569,7 +8569,7 @@
           <p:cNvPr id="10" name="">
             <a:extLst xmlns:a="http://schemas.openxmlformats.org/drawingml/2006/main">
               <a:ext uri="{FF2B5EF4-FFF2-40B4-BE49-F238E27FC236}">
-                <a16:creationId xmlns:a16="http://schemas.microsoft.com/office/drawing/2014/main" id="{E568CD4C-6698-43AC-BE75-9F992C875E81}"/>
+                <a16:creationId xmlns:a16="http://schemas.microsoft.com/office/drawing/2014/main" id="{78F3DFF2-ED8C-433E-9B5E-83DED2B49337}"/>
               </a:ext>
             </a:extLst>
           </p:cNvPr>
@@ -8602,7 +8602,7 @@
           <p:cNvPr id="11" name="">
             <a:extLst xmlns:a="http://schemas.openxmlformats.org/drawingml/2006/main">
               <a:ext uri="{FF2B5EF4-FFF2-40B4-BE49-F238E27FC236}">
-                <a16:creationId xmlns:a16="http://schemas.microsoft.com/office/drawing/2014/main" id="{D8530EFC-99C6-45E2-91BC-C3F07D324F09}"/>
+                <a16:creationId xmlns:a16="http://schemas.microsoft.com/office/drawing/2014/main" id="{F818A189-2DDB-43A0-B067-1157DCDEACDD}"/>
               </a:ext>
             </a:extLst>
           </p:cNvPr>
@@ -8664,7 +8664,7 @@
           <p:cNvPr id="12" name="">
             <a:extLst xmlns:a="http://schemas.openxmlformats.org/drawingml/2006/main">
               <a:ext uri="{FF2B5EF4-FFF2-40B4-BE49-F238E27FC236}">
-                <a16:creationId xmlns:a16="http://schemas.microsoft.com/office/drawing/2014/main" id="{C9BFAE81-CEA9-4AB6-9A29-8CC0F1FC02B3}"/>
+                <a16:creationId xmlns:a16="http://schemas.microsoft.com/office/drawing/2014/main" id="{B0A04E40-41CD-4996-B002-E4240C1CB181}"/>
               </a:ext>
             </a:extLst>
           </p:cNvPr>
@@ -8728,7 +8728,7 @@
           <p:cNvPr id="13" name="">
             <a:extLst xmlns:a="http://schemas.openxmlformats.org/drawingml/2006/main">
               <a:ext uri="{FF2B5EF4-FFF2-40B4-BE49-F238E27FC236}">
-                <a16:creationId xmlns:a16="http://schemas.microsoft.com/office/drawing/2014/main" id="{0FC4B411-129C-4D12-98DE-EBD09CBFA2EB}"/>
+                <a16:creationId xmlns:a16="http://schemas.microsoft.com/office/drawing/2014/main" id="{E563C1CF-635F-4C92-9184-0C452D0DDFC7}"/>
               </a:ext>
             </a:extLst>
           </p:cNvPr>
@@ -8805,7 +8805,7 @@
                 <a:ea typeface="Calibri"/>
                 <a:cs typeface="Calibri"/>
               </a:rPr>
-              <a:t>variant-level Table S2</a:t>
+              <a:t>variant-level dataset</a:t>
             </a:r>
           </a:p>
         </p:txBody>
@@ -8815,7 +8815,7 @@
           <p:cNvPr id="14" name="">
             <a:extLst xmlns:a="http://schemas.openxmlformats.org/drawingml/2006/main">
               <a:ext uri="{FF2B5EF4-FFF2-40B4-BE49-F238E27FC236}">
-                <a16:creationId xmlns:a16="http://schemas.microsoft.com/office/drawing/2014/main" id="{D0D825F7-7179-44ED-8A61-5EDE65B24181}"/>
+                <a16:creationId xmlns:a16="http://schemas.microsoft.com/office/drawing/2014/main" id="{E5584245-1571-40D2-B4D9-4576403778CB}"/>
               </a:ext>
             </a:extLst>
           </p:cNvPr>
@@ -8879,7 +8879,7 @@
           <p:cNvPr id="15" name="">
             <a:extLst xmlns:a="http://schemas.openxmlformats.org/drawingml/2006/main">
               <a:ext uri="{FF2B5EF4-FFF2-40B4-BE49-F238E27FC236}">
-                <a16:creationId xmlns:a16="http://schemas.microsoft.com/office/drawing/2014/main" id="{FC3F4A86-23C9-4AFF-B652-C1B4A8DC5B2C}"/>
+                <a16:creationId xmlns:a16="http://schemas.microsoft.com/office/drawing/2014/main" id="{5D6E623B-D1AD-4712-B0D0-BBA2E9B094B0}"/>
               </a:ext>
             </a:extLst>
           </p:cNvPr>
@@ -8912,7 +8912,7 @@
           <p:cNvPr id="16" name="">
             <a:extLst xmlns:a="http://schemas.openxmlformats.org/drawingml/2006/main">
               <a:ext uri="{FF2B5EF4-FFF2-40B4-BE49-F238E27FC236}">
-                <a16:creationId xmlns:a16="http://schemas.microsoft.com/office/drawing/2014/main" id="{6F23A4FF-D619-4BB7-BC93-4908CD54EBD1}"/>
+                <a16:creationId xmlns:a16="http://schemas.microsoft.com/office/drawing/2014/main" id="{19A93860-C8D4-4269-B66E-47C335CEDBEA}"/>
               </a:ext>
             </a:extLst>
           </p:cNvPr>
@@ -8974,7 +8974,7 @@
           <p:cNvPr id="17" name="">
             <a:extLst xmlns:a="http://schemas.openxmlformats.org/drawingml/2006/main">
               <a:ext uri="{FF2B5EF4-FFF2-40B4-BE49-F238E27FC236}">
-                <a16:creationId xmlns:a16="http://schemas.microsoft.com/office/drawing/2014/main" id="{54DB9304-0B61-4D38-A01F-2820DCEDEA0F}"/>
+                <a16:creationId xmlns:a16="http://schemas.microsoft.com/office/drawing/2014/main" id="{A1BDB661-CEA3-456A-B78E-BD305987F2F1}"/>
               </a:ext>
             </a:extLst>
           </p:cNvPr>
@@ -9038,7 +9038,7 @@
           <p:cNvPr id="18" name="">
             <a:extLst xmlns:a="http://schemas.openxmlformats.org/drawingml/2006/main">
               <a:ext uri="{FF2B5EF4-FFF2-40B4-BE49-F238E27FC236}">
-                <a16:creationId xmlns:a16="http://schemas.microsoft.com/office/drawing/2014/main" id="{B27449E3-3614-4405-9A77-784C8B31D42D}"/>
+                <a16:creationId xmlns:a16="http://schemas.microsoft.com/office/drawing/2014/main" id="{A18DCD89-126C-46B9-B469-1306285A67A8}"/>
               </a:ext>
             </a:extLst>
           </p:cNvPr>
@@ -9125,7 +9125,7 @@
           <p:cNvPr id="19" name="">
             <a:extLst xmlns:a="http://schemas.openxmlformats.org/drawingml/2006/main">
               <a:ext uri="{FF2B5EF4-FFF2-40B4-BE49-F238E27FC236}">
-                <a16:creationId xmlns:a16="http://schemas.microsoft.com/office/drawing/2014/main" id="{5A2D4409-CDC2-417B-B94C-3965E99518CA}"/>
+                <a16:creationId xmlns:a16="http://schemas.microsoft.com/office/drawing/2014/main" id="{6475D8B8-D681-41D4-B981-D2C3EC58C035}"/>
               </a:ext>
             </a:extLst>
           </p:cNvPr>
@@ -9189,7 +9189,7 @@
           <p:cNvPr id="20" name="">
             <a:extLst xmlns:a="http://schemas.openxmlformats.org/drawingml/2006/main">
               <a:ext uri="{FF2B5EF4-FFF2-40B4-BE49-F238E27FC236}">
-                <a16:creationId xmlns:a16="http://schemas.microsoft.com/office/drawing/2014/main" id="{F5A73EED-5AB2-45A7-B90B-9BD3397C7D84}"/>
+                <a16:creationId xmlns:a16="http://schemas.microsoft.com/office/drawing/2014/main" id="{E57F68E5-FBCE-439E-B23F-B3A59677527A}"/>
               </a:ext>
             </a:extLst>
           </p:cNvPr>
@@ -9222,7 +9222,7 @@
           <p:cNvPr id="21" name="">
             <a:extLst xmlns:a="http://schemas.openxmlformats.org/drawingml/2006/main">
               <a:ext uri="{FF2B5EF4-FFF2-40B4-BE49-F238E27FC236}">
-                <a16:creationId xmlns:a16="http://schemas.microsoft.com/office/drawing/2014/main" id="{7C985BB6-9405-4C70-A98F-66E304981910}"/>
+                <a16:creationId xmlns:a16="http://schemas.microsoft.com/office/drawing/2014/main" id="{9D82FD43-8B91-41A6-8320-CA810F4B0D6A}"/>
               </a:ext>
             </a:extLst>
           </p:cNvPr>
@@ -9284,7 +9284,7 @@
           <p:cNvPr id="22" name="">
             <a:extLst xmlns:a="http://schemas.openxmlformats.org/drawingml/2006/main">
               <a:ext uri="{FF2B5EF4-FFF2-40B4-BE49-F238E27FC236}">
-                <a16:creationId xmlns:a16="http://schemas.microsoft.com/office/drawing/2014/main" id="{18A8855F-D5B6-4ECD-9FC7-21B7DF31756D}"/>
+                <a16:creationId xmlns:a16="http://schemas.microsoft.com/office/drawing/2014/main" id="{2AFC349E-EEF3-42BC-8B12-321D16DA5D0C}"/>
               </a:ext>
             </a:extLst>
           </p:cNvPr>
@@ -9348,7 +9348,7 @@
           <p:cNvPr id="23" name="">
             <a:extLst xmlns:a="http://schemas.openxmlformats.org/drawingml/2006/main">
               <a:ext uri="{FF2B5EF4-FFF2-40B4-BE49-F238E27FC236}">
-                <a16:creationId xmlns:a16="http://schemas.microsoft.com/office/drawing/2014/main" id="{682C1F65-6D2D-4A8A-90B7-73679B9E0589}"/>
+                <a16:creationId xmlns:a16="http://schemas.microsoft.com/office/drawing/2014/main" id="{E659335B-A1F0-45E8-B43B-D52F2E032BAF}"/>
               </a:ext>
             </a:extLst>
           </p:cNvPr>
@@ -9435,7 +9435,7 @@
           <p:cNvPr id="24" name="">
             <a:extLst xmlns:a="http://schemas.openxmlformats.org/drawingml/2006/main">
               <a:ext uri="{FF2B5EF4-FFF2-40B4-BE49-F238E27FC236}">
-                <a16:creationId xmlns:a16="http://schemas.microsoft.com/office/drawing/2014/main" id="{4C917667-39DD-48C6-9C01-D59D11A8F184}"/>
+                <a16:creationId xmlns:a16="http://schemas.microsoft.com/office/drawing/2014/main" id="{55169864-36CB-4415-927B-E89AD88D41BC}"/>
               </a:ext>
             </a:extLst>
           </p:cNvPr>
@@ -9468,7 +9468,7 @@
           <p:cNvPr id="25" name="">
             <a:extLst xmlns:a="http://schemas.openxmlformats.org/drawingml/2006/main">
               <a:ext uri="{FF2B5EF4-FFF2-40B4-BE49-F238E27FC236}">
-                <a16:creationId xmlns:a16="http://schemas.microsoft.com/office/drawing/2014/main" id="{9324F243-7B8F-4E90-9EC4-E504CA1C3A4A}"/>
+                <a16:creationId xmlns:a16="http://schemas.microsoft.com/office/drawing/2014/main" id="{A144A547-CBF0-424C-ABFF-80DB7C185620}"/>
               </a:ext>
             </a:extLst>
           </p:cNvPr>
@@ -9530,7 +9530,7 @@
           <p:cNvPr id="26" name="">
             <a:extLst xmlns:a="http://schemas.openxmlformats.org/drawingml/2006/main">
               <a:ext uri="{FF2B5EF4-FFF2-40B4-BE49-F238E27FC236}">
-                <a16:creationId xmlns:a16="http://schemas.microsoft.com/office/drawing/2014/main" id="{AEA1D058-F6BE-40AD-8F8B-2397C1DDF4D6}"/>
+                <a16:creationId xmlns:a16="http://schemas.microsoft.com/office/drawing/2014/main" id="{F50725A1-9111-4417-B52F-47DFD66916AD}"/>
               </a:ext>
             </a:extLst>
           </p:cNvPr>
@@ -9594,7 +9594,7 @@
           <p:cNvPr id="27" name="">
             <a:extLst xmlns:a="http://schemas.openxmlformats.org/drawingml/2006/main">
               <a:ext uri="{FF2B5EF4-FFF2-40B4-BE49-F238E27FC236}">
-                <a16:creationId xmlns:a16="http://schemas.microsoft.com/office/drawing/2014/main" id="{C0FAF5FC-3119-47E3-BADD-054FF9B49060}"/>
+                <a16:creationId xmlns:a16="http://schemas.microsoft.com/office/drawing/2014/main" id="{339ED7E7-107F-44A2-9DF9-D51F1F5BE458}"/>
               </a:ext>
             </a:extLst>
           </p:cNvPr>
@@ -9681,7 +9681,7 @@
           <p:cNvPr id="28" name="">
             <a:extLst xmlns:a="http://schemas.openxmlformats.org/drawingml/2006/main">
               <a:ext uri="{FF2B5EF4-FFF2-40B4-BE49-F238E27FC236}">
-                <a16:creationId xmlns:a16="http://schemas.microsoft.com/office/drawing/2014/main" id="{4255219B-1957-45A0-80C6-C220A3D2254D}"/>
+                <a16:creationId xmlns:a16="http://schemas.microsoft.com/office/drawing/2014/main" id="{EC5A7688-F522-44F6-A75B-07B69ADC82EA}"/>
               </a:ext>
             </a:extLst>
           </p:cNvPr>
@@ -9745,7 +9745,7 @@
           <p:cNvPr id="29" name="">
             <a:extLst xmlns:a="http://schemas.openxmlformats.org/drawingml/2006/main">
               <a:ext uri="{FF2B5EF4-FFF2-40B4-BE49-F238E27FC236}">
-                <a16:creationId xmlns:a16="http://schemas.microsoft.com/office/drawing/2014/main" id="{3448A370-DB84-47BD-BD9A-A953B7F3E449}"/>
+                <a16:creationId xmlns:a16="http://schemas.microsoft.com/office/drawing/2014/main" id="{F6DB1B5D-0821-4AA4-A4E7-54D648BA86F5}"/>
               </a:ext>
             </a:extLst>
           </p:cNvPr>
@@ -9778,7 +9778,7 @@
           <p:cNvPr id="30" name="">
             <a:extLst xmlns:a="http://schemas.openxmlformats.org/drawingml/2006/main">
               <a:ext uri="{FF2B5EF4-FFF2-40B4-BE49-F238E27FC236}">
-                <a16:creationId xmlns:a16="http://schemas.microsoft.com/office/drawing/2014/main" id="{15AFBF69-4670-4345-86D2-DEF878F50EF6}"/>
+                <a16:creationId xmlns:a16="http://schemas.microsoft.com/office/drawing/2014/main" id="{AEF45749-119A-4B3E-B0D8-82CEA766E756}"/>
               </a:ext>
             </a:extLst>
           </p:cNvPr>
@@ -9840,7 +9840,7 @@
           <p:cNvPr id="31" name="">
             <a:extLst xmlns:a="http://schemas.openxmlformats.org/drawingml/2006/main">
               <a:ext uri="{FF2B5EF4-FFF2-40B4-BE49-F238E27FC236}">
-                <a16:creationId xmlns:a16="http://schemas.microsoft.com/office/drawing/2014/main" id="{98D717D4-1790-45E5-9BA6-6093623FCF3B}"/>
+                <a16:creationId xmlns:a16="http://schemas.microsoft.com/office/drawing/2014/main" id="{943A3CD8-6721-42CC-A29B-12CC0DC8D69D}"/>
               </a:ext>
             </a:extLst>
           </p:cNvPr>
@@ -9904,7 +9904,7 @@
           <p:cNvPr id="32" name="">
             <a:extLst xmlns:a="http://schemas.openxmlformats.org/drawingml/2006/main">
               <a:ext uri="{FF2B5EF4-FFF2-40B4-BE49-F238E27FC236}">
-                <a16:creationId xmlns:a16="http://schemas.microsoft.com/office/drawing/2014/main" id="{224CC569-FC5B-44DE-9560-67E9FDD3D5B5}"/>
+                <a16:creationId xmlns:a16="http://schemas.microsoft.com/office/drawing/2014/main" id="{332996D7-6DAE-4EEF-8585-5A1E48B256B5}"/>
               </a:ext>
             </a:extLst>
           </p:cNvPr>
@@ -9991,7 +9991,7 @@
           <p:cNvPr id="33" name="">
             <a:extLst xmlns:a="http://schemas.openxmlformats.org/drawingml/2006/main">
               <a:ext uri="{FF2B5EF4-FFF2-40B4-BE49-F238E27FC236}">
-                <a16:creationId xmlns:a16="http://schemas.microsoft.com/office/drawing/2014/main" id="{3E00926D-9E71-4CED-AA5A-91351995F7A9}"/>
+                <a16:creationId xmlns:a16="http://schemas.microsoft.com/office/drawing/2014/main" id="{5D49721D-C863-451D-8650-F94301705314}"/>
               </a:ext>
             </a:extLst>
           </p:cNvPr>
@@ -10055,7 +10055,7 @@
           <p:cNvPr id="34" name="">
             <a:extLst xmlns:a="http://schemas.openxmlformats.org/drawingml/2006/main">
               <a:ext uri="{FF2B5EF4-FFF2-40B4-BE49-F238E27FC236}">
-                <a16:creationId xmlns:a16="http://schemas.microsoft.com/office/drawing/2014/main" id="{533BADFC-4CC1-467F-88D4-111AEBB451CF}"/>
+                <a16:creationId xmlns:a16="http://schemas.microsoft.com/office/drawing/2014/main" id="{D9D32BEC-82DB-4FA9-93EF-E782D6B8B144}"/>
               </a:ext>
             </a:extLst>
           </p:cNvPr>
@@ -10088,7 +10088,7 @@
           <p:cNvPr id="35" name="">
             <a:extLst xmlns:a="http://schemas.openxmlformats.org/drawingml/2006/main">
               <a:ext uri="{FF2B5EF4-FFF2-40B4-BE49-F238E27FC236}">
-                <a16:creationId xmlns:a16="http://schemas.microsoft.com/office/drawing/2014/main" id="{37F9E414-91BF-4238-9B38-4C738695E132}"/>
+                <a16:creationId xmlns:a16="http://schemas.microsoft.com/office/drawing/2014/main" id="{2C28716A-BBD4-4487-B221-4C971ED84D33}"/>
               </a:ext>
             </a:extLst>
           </p:cNvPr>
@@ -10150,7 +10150,7 @@
           <p:cNvPr id="36" name="">
             <a:extLst xmlns:a="http://schemas.openxmlformats.org/drawingml/2006/main">
               <a:ext uri="{FF2B5EF4-FFF2-40B4-BE49-F238E27FC236}">
-                <a16:creationId xmlns:a16="http://schemas.microsoft.com/office/drawing/2014/main" id="{76B85E9E-BB8F-4C3E-8DD4-A04259F980FC}"/>
+                <a16:creationId xmlns:a16="http://schemas.microsoft.com/office/drawing/2014/main" id="{3DDDC2E7-8C0B-4267-9964-F5A434757FF2}"/>
               </a:ext>
             </a:extLst>
           </p:cNvPr>
@@ -10214,7 +10214,7 @@
           <p:cNvPr id="37" name="">
             <a:extLst xmlns:a="http://schemas.openxmlformats.org/drawingml/2006/main">
               <a:ext uri="{FF2B5EF4-FFF2-40B4-BE49-F238E27FC236}">
-                <a16:creationId xmlns:a16="http://schemas.microsoft.com/office/drawing/2014/main" id="{53F9AB77-9112-4DA1-BF15-7C57E2017910}"/>
+                <a16:creationId xmlns:a16="http://schemas.microsoft.com/office/drawing/2014/main" id="{F99354BC-395F-4F5F-A117-D26B992DAA9A}"/>
               </a:ext>
             </a:extLst>
           </p:cNvPr>
@@ -10301,7 +10301,7 @@
           <p:cNvPr id="38" name="">
             <a:extLst xmlns:a="http://schemas.openxmlformats.org/drawingml/2006/main">
               <a:ext uri="{FF2B5EF4-FFF2-40B4-BE49-F238E27FC236}">
-                <a16:creationId xmlns:a16="http://schemas.microsoft.com/office/drawing/2014/main" id="{95E9556C-0039-45C3-B0E7-101F3D4CF9C3}"/>
+                <a16:creationId xmlns:a16="http://schemas.microsoft.com/office/drawing/2014/main" id="{10213F91-937A-488C-B6D5-CDC6B9114ABB}"/>
               </a:ext>
             </a:extLst>
           </p:cNvPr>
@@ -10334,7 +10334,7 @@
           <p:cNvPr id="39" name="">
             <a:extLst xmlns:a="http://schemas.openxmlformats.org/drawingml/2006/main">
               <a:ext uri="{FF2B5EF4-FFF2-40B4-BE49-F238E27FC236}">
-                <a16:creationId xmlns:a16="http://schemas.microsoft.com/office/drawing/2014/main" id="{A0883674-BF08-43D3-8228-138137938AFA}"/>
+                <a16:creationId xmlns:a16="http://schemas.microsoft.com/office/drawing/2014/main" id="{9CB559E6-0BE0-48F3-8E00-02C2C76AF631}"/>
               </a:ext>
             </a:extLst>
           </p:cNvPr>
@@ -10456,7 +10456,7 @@
           <p:cNvPr id="5" name="explicit white background">
             <a:extLst xmlns:a="http://schemas.openxmlformats.org/drawingml/2006/main">
               <a:ext uri="{FF2B5EF4-FFF2-40B4-BE49-F238E27FC236}">
-                <a16:creationId xmlns:a16="http://schemas.microsoft.com/office/drawing/2014/main" id="{D86F3C44-7133-42B8-AEE0-2C19D1B0642C}"/>
+                <a16:creationId xmlns:a16="http://schemas.microsoft.com/office/drawing/2014/main" id="{10063230-8ED9-45C0-9AC0-F34DB0310F29}"/>
               </a:ext>
             </a:extLst>
           </p:cNvPr>
@@ -10489,7 +10489,7 @@
           <p:cNvPr id="6" name="HUST red title bar">
             <a:extLst xmlns:a="http://schemas.openxmlformats.org/drawingml/2006/main">
               <a:ext uri="{FF2B5EF4-FFF2-40B4-BE49-F238E27FC236}">
-                <a16:creationId xmlns:a16="http://schemas.microsoft.com/office/drawing/2014/main" id="{C3830F9D-5B63-4A77-9416-830326E86570}"/>
+                <a16:creationId xmlns:a16="http://schemas.microsoft.com/office/drawing/2014/main" id="{21BCC203-5166-4671-A75B-861701D7F609}"/>
               </a:ext>
             </a:extLst>
           </p:cNvPr>
@@ -10522,7 +10522,7 @@
           <p:cNvPr id="7" name="HUST gold divider">
             <a:extLst xmlns:a="http://schemas.openxmlformats.org/drawingml/2006/main">
               <a:ext uri="{FF2B5EF4-FFF2-40B4-BE49-F238E27FC236}">
-                <a16:creationId xmlns:a16="http://schemas.microsoft.com/office/drawing/2014/main" id="{2F419D04-8138-40CC-9E5F-290C2D82104C}"/>
+                <a16:creationId xmlns:a16="http://schemas.microsoft.com/office/drawing/2014/main" id="{B8350A8C-2DFC-4875-BDBB-DC8E74FD5C22}"/>
               </a:ext>
             </a:extLst>
           </p:cNvPr>
@@ -10555,7 +10555,7 @@
           <p:cNvPr id="8" name="">
             <a:extLst xmlns:a="http://schemas.openxmlformats.org/drawingml/2006/main">
               <a:ext uri="{FF2B5EF4-FFF2-40B4-BE49-F238E27FC236}">
-                <a16:creationId xmlns:a16="http://schemas.microsoft.com/office/drawing/2014/main" id="{63D16E20-67F5-48EC-9E58-DD14A2D6510B}"/>
+                <a16:creationId xmlns:a16="http://schemas.microsoft.com/office/drawing/2014/main" id="{644924B1-178C-453A-A00B-FDF1D750ACE8}"/>
               </a:ext>
             </a:extLst>
           </p:cNvPr>
@@ -10619,7 +10619,7 @@
           <p:cNvPr id="9" name="">
             <a:extLst xmlns:a="http://schemas.openxmlformats.org/drawingml/2006/main">
               <a:ext uri="{FF2B5EF4-FFF2-40B4-BE49-F238E27FC236}">
-                <a16:creationId xmlns:a16="http://schemas.microsoft.com/office/drawing/2014/main" id="{E8EFA19C-09BB-40C3-9D98-AF11813BE335}"/>
+                <a16:creationId xmlns:a16="http://schemas.microsoft.com/office/drawing/2014/main" id="{4FA4A853-397C-4ADE-AEBD-AEB91E0CB7B9}"/>
               </a:ext>
             </a:extLst>
           </p:cNvPr>
@@ -10652,7 +10652,7 @@
           <p:cNvPr id="10" name="">
             <a:extLst xmlns:a="http://schemas.openxmlformats.org/drawingml/2006/main">
               <a:ext uri="{FF2B5EF4-FFF2-40B4-BE49-F238E27FC236}">
-                <a16:creationId xmlns:a16="http://schemas.microsoft.com/office/drawing/2014/main" id="{D7D64423-5050-426C-A1AB-167EE0146A9C}"/>
+                <a16:creationId xmlns:a16="http://schemas.microsoft.com/office/drawing/2014/main" id="{9583634B-2184-44F8-B78D-3A92D37DD005}"/>
               </a:ext>
             </a:extLst>
           </p:cNvPr>
@@ -10685,7 +10685,7 @@
           <p:cNvPr id="11" name="">
             <a:extLst xmlns:a="http://schemas.openxmlformats.org/drawingml/2006/main">
               <a:ext uri="{FF2B5EF4-FFF2-40B4-BE49-F238E27FC236}">
-                <a16:creationId xmlns:a16="http://schemas.microsoft.com/office/drawing/2014/main" id="{1CB62F45-374A-4DE4-92ED-36FF7E8605DB}"/>
+                <a16:creationId xmlns:a16="http://schemas.microsoft.com/office/drawing/2014/main" id="{29B72CE5-DAB0-4982-933A-C3419F186A85}"/>
               </a:ext>
             </a:extLst>
           </p:cNvPr>
@@ -10749,7 +10749,7 @@
           <p:cNvPr id="12" name="">
             <a:extLst xmlns:a="http://schemas.openxmlformats.org/drawingml/2006/main">
               <a:ext uri="{FF2B5EF4-FFF2-40B4-BE49-F238E27FC236}">
-                <a16:creationId xmlns:a16="http://schemas.microsoft.com/office/drawing/2014/main" id="{D91439F1-1117-42E7-A7CC-F57F76C8675D}"/>
+                <a16:creationId xmlns:a16="http://schemas.microsoft.com/office/drawing/2014/main" id="{D7933848-3445-44A9-938A-9FE5EA423402}"/>
               </a:ext>
             </a:extLst>
           </p:cNvPr>
@@ -10910,7 +10910,7 @@
           <p:cNvPr id="13" name="">
             <a:extLst xmlns:a="http://schemas.openxmlformats.org/drawingml/2006/main">
               <a:ext uri="{FF2B5EF4-FFF2-40B4-BE49-F238E27FC236}">
-                <a16:creationId xmlns:a16="http://schemas.microsoft.com/office/drawing/2014/main" id="{5932E2F1-47DB-42D9-9152-6DE903A8756A}"/>
+                <a16:creationId xmlns:a16="http://schemas.microsoft.com/office/drawing/2014/main" id="{D3649D2C-B6BF-4CE2-B11D-EDF3C541F2FA}"/>
               </a:ext>
             </a:extLst>
           </p:cNvPr>
@@ -10943,7 +10943,7 @@
           <p:cNvPr id="14" name="">
             <a:extLst xmlns:a="http://schemas.openxmlformats.org/drawingml/2006/main">
               <a:ext uri="{FF2B5EF4-FFF2-40B4-BE49-F238E27FC236}">
-                <a16:creationId xmlns:a16="http://schemas.microsoft.com/office/drawing/2014/main" id="{B87A7797-0AB3-4872-ACA9-684C1E9A9AA4}"/>
+                <a16:creationId xmlns:a16="http://schemas.microsoft.com/office/drawing/2014/main" id="{A8FDBD59-FE41-43C8-A550-230A1B9D8D65}"/>
               </a:ext>
             </a:extLst>
           </p:cNvPr>
@@ -11007,7 +11007,7 @@
           <p:cNvPr id="15" name="">
             <a:extLst xmlns:a="http://schemas.openxmlformats.org/drawingml/2006/main">
               <a:ext uri="{FF2B5EF4-FFF2-40B4-BE49-F238E27FC236}">
-                <a16:creationId xmlns:a16="http://schemas.microsoft.com/office/drawing/2014/main" id="{4DB3A69E-12EC-4E6E-9FE3-297F9E827278}"/>
+                <a16:creationId xmlns:a16="http://schemas.microsoft.com/office/drawing/2014/main" id="{4C2454BE-FB4C-4461-A487-87BB9BF75C07}"/>
               </a:ext>
             </a:extLst>
           </p:cNvPr>
@@ -11071,7 +11071,7 @@
           <p:cNvPr id="16" name="">
             <a:extLst xmlns:a="http://schemas.openxmlformats.org/drawingml/2006/main">
               <a:ext uri="{FF2B5EF4-FFF2-40B4-BE49-F238E27FC236}">
-                <a16:creationId xmlns:a16="http://schemas.microsoft.com/office/drawing/2014/main" id="{3EF20715-D155-4ECE-84C9-8446FDAB6EDF}"/>
+                <a16:creationId xmlns:a16="http://schemas.microsoft.com/office/drawing/2014/main" id="{E890E137-B071-457F-930F-714DC1C09F3D}"/>
               </a:ext>
             </a:extLst>
           </p:cNvPr>
@@ -11104,7 +11104,7 @@
           <p:cNvPr id="17" name="">
             <a:extLst xmlns:a="http://schemas.openxmlformats.org/drawingml/2006/main">
               <a:ext uri="{FF2B5EF4-FFF2-40B4-BE49-F238E27FC236}">
-                <a16:creationId xmlns:a16="http://schemas.microsoft.com/office/drawing/2014/main" id="{3CCD58AE-1600-41F6-92A9-47E11251198D}"/>
+                <a16:creationId xmlns:a16="http://schemas.microsoft.com/office/drawing/2014/main" id="{47AB56B0-EFF5-4F93-B14B-C211B6AEDB62}"/>
               </a:ext>
             </a:extLst>
           </p:cNvPr>
@@ -11168,7 +11168,7 @@
           <p:cNvPr id="18" name="">
             <a:extLst xmlns:a="http://schemas.openxmlformats.org/drawingml/2006/main">
               <a:ext uri="{FF2B5EF4-FFF2-40B4-BE49-F238E27FC236}">
-                <a16:creationId xmlns:a16="http://schemas.microsoft.com/office/drawing/2014/main" id="{82F34233-F923-48D1-B327-25FE230E9808}"/>
+                <a16:creationId xmlns:a16="http://schemas.microsoft.com/office/drawing/2014/main" id="{74EB3366-E775-4959-84C6-61E04856200B}"/>
               </a:ext>
             </a:extLst>
           </p:cNvPr>
@@ -11232,7 +11232,7 @@
           <p:cNvPr id="19" name="">
             <a:extLst xmlns:a="http://schemas.openxmlformats.org/drawingml/2006/main">
               <a:ext uri="{FF2B5EF4-FFF2-40B4-BE49-F238E27FC236}">
-                <a16:creationId xmlns:a16="http://schemas.microsoft.com/office/drawing/2014/main" id="{0F798AE8-D69D-4F94-AD2C-FB17AB05E9C1}"/>
+                <a16:creationId xmlns:a16="http://schemas.microsoft.com/office/drawing/2014/main" id="{9B32FB79-CAA9-4CE6-B308-E3D9D27A51DC}"/>
               </a:ext>
             </a:extLst>
           </p:cNvPr>
@@ -11265,7 +11265,7 @@
           <p:cNvPr id="20" name="">
             <a:extLst xmlns:a="http://schemas.openxmlformats.org/drawingml/2006/main">
               <a:ext uri="{FF2B5EF4-FFF2-40B4-BE49-F238E27FC236}">
-                <a16:creationId xmlns:a16="http://schemas.microsoft.com/office/drawing/2014/main" id="{B5C221C1-80D6-48E5-B8E2-FC492A1335C4}"/>
+                <a16:creationId xmlns:a16="http://schemas.microsoft.com/office/drawing/2014/main" id="{89BD6B30-09A9-4AB8-87B4-35CB5CFE81C6}"/>
               </a:ext>
             </a:extLst>
           </p:cNvPr>
@@ -11329,7 +11329,7 @@
           <p:cNvPr id="21" name="">
             <a:extLst xmlns:a="http://schemas.openxmlformats.org/drawingml/2006/main">
               <a:ext uri="{FF2B5EF4-FFF2-40B4-BE49-F238E27FC236}">
-                <a16:creationId xmlns:a16="http://schemas.microsoft.com/office/drawing/2014/main" id="{A87332A4-43B6-435C-8C90-14FE5E2076B2}"/>
+                <a16:creationId xmlns:a16="http://schemas.microsoft.com/office/drawing/2014/main" id="{42108FFA-84C6-4BDE-A86D-3BA69480458A}"/>
               </a:ext>
             </a:extLst>
           </p:cNvPr>
@@ -11393,7 +11393,7 @@
           <p:cNvPr id="22" name="">
             <a:extLst xmlns:a="http://schemas.openxmlformats.org/drawingml/2006/main">
               <a:ext uri="{FF2B5EF4-FFF2-40B4-BE49-F238E27FC236}">
-                <a16:creationId xmlns:a16="http://schemas.microsoft.com/office/drawing/2014/main" id="{5676DCA9-31C4-448F-8045-7945F5A1E1F8}"/>
+                <a16:creationId xmlns:a16="http://schemas.microsoft.com/office/drawing/2014/main" id="{630C6657-33BC-4A55-A414-DB112B8B7DAA}"/>
               </a:ext>
             </a:extLst>
           </p:cNvPr>
@@ -11426,7 +11426,7 @@
           <p:cNvPr id="23" name="">
             <a:extLst xmlns:a="http://schemas.openxmlformats.org/drawingml/2006/main">
               <a:ext uri="{FF2B5EF4-FFF2-40B4-BE49-F238E27FC236}">
-                <a16:creationId xmlns:a16="http://schemas.microsoft.com/office/drawing/2014/main" id="{3BA559B2-33AF-494C-B190-B35E3F5BA2B7}"/>
+                <a16:creationId xmlns:a16="http://schemas.microsoft.com/office/drawing/2014/main" id="{26B15C23-A9BD-4417-9496-5E40A021D463}"/>
               </a:ext>
             </a:extLst>
           </p:cNvPr>
@@ -11548,7 +11548,7 @@
           <p:cNvPr id="5" name="explicit white background">
             <a:extLst xmlns:a="http://schemas.openxmlformats.org/drawingml/2006/main">
               <a:ext uri="{FF2B5EF4-FFF2-40B4-BE49-F238E27FC236}">
-                <a16:creationId xmlns:a16="http://schemas.microsoft.com/office/drawing/2014/main" id="{8A2A3A7B-043E-4320-96A0-2725576F619E}"/>
+                <a16:creationId xmlns:a16="http://schemas.microsoft.com/office/drawing/2014/main" id="{7A39FC8B-59F0-4002-9489-533D35F77AB2}"/>
               </a:ext>
             </a:extLst>
           </p:cNvPr>
@@ -11581,7 +11581,7 @@
           <p:cNvPr id="6" name="HUST red title bar">
             <a:extLst xmlns:a="http://schemas.openxmlformats.org/drawingml/2006/main">
               <a:ext uri="{FF2B5EF4-FFF2-40B4-BE49-F238E27FC236}">
-                <a16:creationId xmlns:a16="http://schemas.microsoft.com/office/drawing/2014/main" id="{A5FAE516-DCF2-4A50-90F7-B4EDAE943F28}"/>
+                <a16:creationId xmlns:a16="http://schemas.microsoft.com/office/drawing/2014/main" id="{A9330BFA-8177-4D5C-9E9E-02B33E8CB808}"/>
               </a:ext>
             </a:extLst>
           </p:cNvPr>
@@ -11614,7 +11614,7 @@
           <p:cNvPr id="7" name="HUST gold divider">
             <a:extLst xmlns:a="http://schemas.openxmlformats.org/drawingml/2006/main">
               <a:ext uri="{FF2B5EF4-FFF2-40B4-BE49-F238E27FC236}">
-                <a16:creationId xmlns:a16="http://schemas.microsoft.com/office/drawing/2014/main" id="{32E4276B-8771-453B-AFB1-72B3454AD650}"/>
+                <a16:creationId xmlns:a16="http://schemas.microsoft.com/office/drawing/2014/main" id="{B98F2732-3C03-478E-B823-02CB61ABBF27}"/>
               </a:ext>
             </a:extLst>
           </p:cNvPr>
@@ -11647,7 +11647,7 @@
           <p:cNvPr id="8" name="">
             <a:extLst xmlns:a="http://schemas.openxmlformats.org/drawingml/2006/main">
               <a:ext uri="{FF2B5EF4-FFF2-40B4-BE49-F238E27FC236}">
-                <a16:creationId xmlns:a16="http://schemas.microsoft.com/office/drawing/2014/main" id="{886A5E6E-EE4B-45C7-BE4E-BBA7F4EB21EE}"/>
+                <a16:creationId xmlns:a16="http://schemas.microsoft.com/office/drawing/2014/main" id="{AB452110-8168-4525-AD88-2FD04D8B2E54}"/>
               </a:ext>
             </a:extLst>
           </p:cNvPr>
@@ -11711,7 +11711,7 @@
           <p:cNvPr id="9" name="">
             <a:extLst xmlns:a="http://schemas.openxmlformats.org/drawingml/2006/main">
               <a:ext uri="{FF2B5EF4-FFF2-40B4-BE49-F238E27FC236}">
-                <a16:creationId xmlns:a16="http://schemas.microsoft.com/office/drawing/2014/main" id="{01AC3341-0920-4925-A67D-98A7EE6780A9}"/>
+                <a16:creationId xmlns:a16="http://schemas.microsoft.com/office/drawing/2014/main" id="{48CEAB4C-C1A3-4478-AA43-B9B0D94A83FD}"/>
               </a:ext>
             </a:extLst>
           </p:cNvPr>
@@ -11744,7 +11744,7 @@
           <p:cNvPr id="10" name="">
             <a:extLst xmlns:a="http://schemas.openxmlformats.org/drawingml/2006/main">
               <a:ext uri="{FF2B5EF4-FFF2-40B4-BE49-F238E27FC236}">
-                <a16:creationId xmlns:a16="http://schemas.microsoft.com/office/drawing/2014/main" id="{D205FEF4-78C1-4BBC-9C5E-46E16DE2BAF8}"/>
+                <a16:creationId xmlns:a16="http://schemas.microsoft.com/office/drawing/2014/main" id="{7AA02996-344D-4472-80C2-B09673043DCC}"/>
               </a:ext>
             </a:extLst>
           </p:cNvPr>
@@ -11777,7 +11777,7 @@
           <p:cNvPr id="11" name="">
             <a:extLst xmlns:a="http://schemas.openxmlformats.org/drawingml/2006/main">
               <a:ext uri="{FF2B5EF4-FFF2-40B4-BE49-F238E27FC236}">
-                <a16:creationId xmlns:a16="http://schemas.microsoft.com/office/drawing/2014/main" id="{EDA5E530-CB59-4B3B-A07A-6BC5C18659C9}"/>
+                <a16:creationId xmlns:a16="http://schemas.microsoft.com/office/drawing/2014/main" id="{0034A9D9-01C6-43E0-8C5D-92507D443DAB}"/>
               </a:ext>
             </a:extLst>
           </p:cNvPr>
@@ -11841,7 +11841,7 @@
           <p:cNvPr id="12" name="">
             <a:extLst xmlns:a="http://schemas.openxmlformats.org/drawingml/2006/main">
               <a:ext uri="{FF2B5EF4-FFF2-40B4-BE49-F238E27FC236}">
-                <a16:creationId xmlns:a16="http://schemas.microsoft.com/office/drawing/2014/main" id="{34ABA152-F063-4C36-AFDD-5016BA48567E}"/>
+                <a16:creationId xmlns:a16="http://schemas.microsoft.com/office/drawing/2014/main" id="{C426068A-2478-4B2D-A71B-063426783455}"/>
               </a:ext>
             </a:extLst>
           </p:cNvPr>
@@ -11905,7 +11905,7 @@
           <p:cNvPr id="13" name="">
             <a:extLst xmlns:a="http://schemas.openxmlformats.org/drawingml/2006/main">
               <a:ext uri="{FF2B5EF4-FFF2-40B4-BE49-F238E27FC236}">
-                <a16:creationId xmlns:a16="http://schemas.microsoft.com/office/drawing/2014/main" id="{F46343EA-79EE-46BF-A1AE-7B9F3EDC54B5}"/>
+                <a16:creationId xmlns:a16="http://schemas.microsoft.com/office/drawing/2014/main" id="{0C8B1AF1-21DC-4CCF-BB87-C86EB115CA7C}"/>
               </a:ext>
             </a:extLst>
           </p:cNvPr>
@@ -11938,7 +11938,7 @@
           <p:cNvPr id="14" name="">
             <a:extLst xmlns:a="http://schemas.openxmlformats.org/drawingml/2006/main">
               <a:ext uri="{FF2B5EF4-FFF2-40B4-BE49-F238E27FC236}">
-                <a16:creationId xmlns:a16="http://schemas.microsoft.com/office/drawing/2014/main" id="{457150F4-AF09-4BD1-9563-585865D0D6B0}"/>
+                <a16:creationId xmlns:a16="http://schemas.microsoft.com/office/drawing/2014/main" id="{1F6397B3-CADF-4D0E-8FBD-419E9E307AD3}"/>
               </a:ext>
             </a:extLst>
           </p:cNvPr>
@@ -12002,7 +12002,7 @@
           <p:cNvPr id="15" name="">
             <a:extLst xmlns:a="http://schemas.openxmlformats.org/drawingml/2006/main">
               <a:ext uri="{FF2B5EF4-FFF2-40B4-BE49-F238E27FC236}">
-                <a16:creationId xmlns:a16="http://schemas.microsoft.com/office/drawing/2014/main" id="{CC627F9C-06F1-40BC-9CA7-92A912DEB0B9}"/>
+                <a16:creationId xmlns:a16="http://schemas.microsoft.com/office/drawing/2014/main" id="{16CA3E55-CF81-4F82-917C-50FD2AC6301C}"/>
               </a:ext>
             </a:extLst>
           </p:cNvPr>
@@ -12066,7 +12066,7 @@
           <p:cNvPr id="16" name="">
             <a:extLst xmlns:a="http://schemas.openxmlformats.org/drawingml/2006/main">
               <a:ext uri="{FF2B5EF4-FFF2-40B4-BE49-F238E27FC236}">
-                <a16:creationId xmlns:a16="http://schemas.microsoft.com/office/drawing/2014/main" id="{F4544326-F8AB-47E4-BDAF-6C4CC7BD3A7E}"/>
+                <a16:creationId xmlns:a16="http://schemas.microsoft.com/office/drawing/2014/main" id="{405A01D5-6EF4-4DF9-AF4C-BDAF9B40FB31}"/>
               </a:ext>
             </a:extLst>
           </p:cNvPr>
@@ -12099,7 +12099,7 @@
           <p:cNvPr id="17" name="">
             <a:extLst xmlns:a="http://schemas.openxmlformats.org/drawingml/2006/main">
               <a:ext uri="{FF2B5EF4-FFF2-40B4-BE49-F238E27FC236}">
-                <a16:creationId xmlns:a16="http://schemas.microsoft.com/office/drawing/2014/main" id="{6701AABA-F93C-40D5-970D-B25DD59388FA}"/>
+                <a16:creationId xmlns:a16="http://schemas.microsoft.com/office/drawing/2014/main" id="{89CC887F-A1FE-4BD0-9266-B9282025F84D}"/>
               </a:ext>
             </a:extLst>
           </p:cNvPr>
@@ -12163,7 +12163,7 @@
           <p:cNvPr id="18" name="">
             <a:extLst xmlns:a="http://schemas.openxmlformats.org/drawingml/2006/main">
               <a:ext uri="{FF2B5EF4-FFF2-40B4-BE49-F238E27FC236}">
-                <a16:creationId xmlns:a16="http://schemas.microsoft.com/office/drawing/2014/main" id="{8D7B2362-1C7C-4BD4-AAD8-1A20A1D5D791}"/>
+                <a16:creationId xmlns:a16="http://schemas.microsoft.com/office/drawing/2014/main" id="{109E75B9-3B35-49A7-BE2F-24B6F7783457}"/>
               </a:ext>
             </a:extLst>
           </p:cNvPr>
@@ -12227,7 +12227,7 @@
           <p:cNvPr id="19" name="">
             <a:extLst xmlns:a="http://schemas.openxmlformats.org/drawingml/2006/main">
               <a:ext uri="{FF2B5EF4-FFF2-40B4-BE49-F238E27FC236}">
-                <a16:creationId xmlns:a16="http://schemas.microsoft.com/office/drawing/2014/main" id="{C0B0007E-DC6E-4F22-BA16-F176F53B574E}"/>
+                <a16:creationId xmlns:a16="http://schemas.microsoft.com/office/drawing/2014/main" id="{708250F4-C653-4E64-AF28-9F6FB7A6AAB5}"/>
               </a:ext>
             </a:extLst>
           </p:cNvPr>
@@ -12260,7 +12260,7 @@
           <p:cNvPr id="20" name="">
             <a:extLst xmlns:a="http://schemas.openxmlformats.org/drawingml/2006/main">
               <a:ext uri="{FF2B5EF4-FFF2-40B4-BE49-F238E27FC236}">
-                <a16:creationId xmlns:a16="http://schemas.microsoft.com/office/drawing/2014/main" id="{108510CE-703A-4388-9C90-2E1870135A56}"/>
+                <a16:creationId xmlns:a16="http://schemas.microsoft.com/office/drawing/2014/main" id="{FE703FBA-E4D6-4D17-8A7C-16467A7801AD}"/>
               </a:ext>
             </a:extLst>
           </p:cNvPr>
@@ -12324,7 +12324,7 @@
           <p:cNvPr id="21" name="">
             <a:extLst xmlns:a="http://schemas.openxmlformats.org/drawingml/2006/main">
               <a:ext uri="{FF2B5EF4-FFF2-40B4-BE49-F238E27FC236}">
-                <a16:creationId xmlns:a16="http://schemas.microsoft.com/office/drawing/2014/main" id="{908F5830-BDF6-47B6-B6C8-FD4C4BBE6053}"/>
+                <a16:creationId xmlns:a16="http://schemas.microsoft.com/office/drawing/2014/main" id="{158C6389-21A5-42F4-9A53-7F907F235BB1}"/>
               </a:ext>
             </a:extLst>
           </p:cNvPr>
@@ -12388,7 +12388,7 @@
           <p:cNvPr id="22" name="">
             <a:extLst xmlns:a="http://schemas.openxmlformats.org/drawingml/2006/main">
               <a:ext uri="{FF2B5EF4-FFF2-40B4-BE49-F238E27FC236}">
-                <a16:creationId xmlns:a16="http://schemas.microsoft.com/office/drawing/2014/main" id="{65473F49-1F55-41FD-BD91-E617B91CF3FA}"/>
+                <a16:creationId xmlns:a16="http://schemas.microsoft.com/office/drawing/2014/main" id="{DBDCFC88-A976-4272-B185-B6DE1A66E4EE}"/>
               </a:ext>
             </a:extLst>
           </p:cNvPr>
@@ -12452,7 +12452,7 @@
           <p:cNvPr id="23" name="">
             <a:extLst xmlns:a="http://schemas.openxmlformats.org/drawingml/2006/main">
               <a:ext uri="{FF2B5EF4-FFF2-40B4-BE49-F238E27FC236}">
-                <a16:creationId xmlns:a16="http://schemas.microsoft.com/office/drawing/2014/main" id="{8338049F-D93F-47E7-A5CD-9F12837A0EC1}"/>
+                <a16:creationId xmlns:a16="http://schemas.microsoft.com/office/drawing/2014/main" id="{561E95D9-E663-4F9A-AE0F-D4852ED7065E}"/>
               </a:ext>
             </a:extLst>
           </p:cNvPr>
@@ -12485,7 +12485,7 @@
           <p:cNvPr id="24" name="">
             <a:extLst xmlns:a="http://schemas.openxmlformats.org/drawingml/2006/main">
               <a:ext uri="{FF2B5EF4-FFF2-40B4-BE49-F238E27FC236}">
-                <a16:creationId xmlns:a16="http://schemas.microsoft.com/office/drawing/2014/main" id="{E9AEFF00-A701-447D-B01C-2CE2CE1C9B89}"/>
+                <a16:creationId xmlns:a16="http://schemas.microsoft.com/office/drawing/2014/main" id="{9A9FC10F-8F78-412F-8062-273281B84629}"/>
               </a:ext>
             </a:extLst>
           </p:cNvPr>
@@ -12531,7 +12531,7 @@
           <p:cNvPr id="25" name="">
             <a:extLst xmlns:a="http://schemas.openxmlformats.org/drawingml/2006/main">
               <a:ext uri="{FF2B5EF4-FFF2-40B4-BE49-F238E27FC236}">
-                <a16:creationId xmlns:a16="http://schemas.microsoft.com/office/drawing/2014/main" id="{7F69DF55-1324-4256-968A-04B04F325893}"/>
+                <a16:creationId xmlns:a16="http://schemas.microsoft.com/office/drawing/2014/main" id="{4D2524DD-1836-4CAB-8FC6-467CE8F802DB}"/>
               </a:ext>
             </a:extLst>
           </p:cNvPr>
@@ -12595,7 +12595,7 @@
           <p:cNvPr id="26" name="">
             <a:extLst xmlns:a="http://schemas.openxmlformats.org/drawingml/2006/main">
               <a:ext uri="{FF2B5EF4-FFF2-40B4-BE49-F238E27FC236}">
-                <a16:creationId xmlns:a16="http://schemas.microsoft.com/office/drawing/2014/main" id="{C2326145-16EA-4D8C-8460-73E51E7DA9CE}"/>
+                <a16:creationId xmlns:a16="http://schemas.microsoft.com/office/drawing/2014/main" id="{48D2B0C2-096E-4F31-A3B8-146C81A57A9C}"/>
               </a:ext>
             </a:extLst>
           </p:cNvPr>
@@ -12659,7 +12659,7 @@
           <p:cNvPr id="27" name="">
             <a:extLst xmlns:a="http://schemas.openxmlformats.org/drawingml/2006/main">
               <a:ext uri="{FF2B5EF4-FFF2-40B4-BE49-F238E27FC236}">
-                <a16:creationId xmlns:a16="http://schemas.microsoft.com/office/drawing/2014/main" id="{750447B6-0B76-4D94-B110-B7BDB629FB62}"/>
+                <a16:creationId xmlns:a16="http://schemas.microsoft.com/office/drawing/2014/main" id="{7F22B860-E6D9-4277-BA90-A2D17B782C73}"/>
               </a:ext>
             </a:extLst>
           </p:cNvPr>
@@ -12692,7 +12692,7 @@
           <p:cNvPr id="28" name="">
             <a:extLst xmlns:a="http://schemas.openxmlformats.org/drawingml/2006/main">
               <a:ext uri="{FF2B5EF4-FFF2-40B4-BE49-F238E27FC236}">
-                <a16:creationId xmlns:a16="http://schemas.microsoft.com/office/drawing/2014/main" id="{465EF942-A22A-4955-A406-85D6605DE9EC}"/>
+                <a16:creationId xmlns:a16="http://schemas.microsoft.com/office/drawing/2014/main" id="{69382FCE-BD70-45D4-AD53-382A6F493716}"/>
               </a:ext>
             </a:extLst>
           </p:cNvPr>
@@ -12756,7 +12756,7 @@
           <p:cNvPr id="29" name="">
             <a:extLst xmlns:a="http://schemas.openxmlformats.org/drawingml/2006/main">
               <a:ext uri="{FF2B5EF4-FFF2-40B4-BE49-F238E27FC236}">
-                <a16:creationId xmlns:a16="http://schemas.microsoft.com/office/drawing/2014/main" id="{888095E1-E38B-4C41-A117-304E439C0BF1}"/>
+                <a16:creationId xmlns:a16="http://schemas.microsoft.com/office/drawing/2014/main" id="{AE57A860-94C1-444C-BB87-2370C1C342D6}"/>
               </a:ext>
             </a:extLst>
           </p:cNvPr>
@@ -12820,7 +12820,7 @@
           <p:cNvPr id="30" name="">
             <a:extLst xmlns:a="http://schemas.openxmlformats.org/drawingml/2006/main">
               <a:ext uri="{FF2B5EF4-FFF2-40B4-BE49-F238E27FC236}">
-                <a16:creationId xmlns:a16="http://schemas.microsoft.com/office/drawing/2014/main" id="{9B1D7D7C-1628-4B6B-B1E3-D36EDA89B807}"/>
+                <a16:creationId xmlns:a16="http://schemas.microsoft.com/office/drawing/2014/main" id="{CD5B9A23-BF75-4491-9FFC-BCD7E51CD27E}"/>
               </a:ext>
             </a:extLst>
           </p:cNvPr>
@@ -12884,7 +12884,7 @@
           <p:cNvPr id="31" name="">
             <a:extLst xmlns:a="http://schemas.openxmlformats.org/drawingml/2006/main">
               <a:ext uri="{FF2B5EF4-FFF2-40B4-BE49-F238E27FC236}">
-                <a16:creationId xmlns:a16="http://schemas.microsoft.com/office/drawing/2014/main" id="{805CFE59-2666-470D-B739-484F92BE1A86}"/>
+                <a16:creationId xmlns:a16="http://schemas.microsoft.com/office/drawing/2014/main" id="{F9FED309-9ECE-4A02-A017-0DC4134D02F4}"/>
               </a:ext>
             </a:extLst>
           </p:cNvPr>
@@ -12917,7 +12917,7 @@
           <p:cNvPr id="32" name="">
             <a:extLst xmlns:a="http://schemas.openxmlformats.org/drawingml/2006/main">
               <a:ext uri="{FF2B5EF4-FFF2-40B4-BE49-F238E27FC236}">
-                <a16:creationId xmlns:a16="http://schemas.microsoft.com/office/drawing/2014/main" id="{A3C7FE77-918A-42A1-A31F-090F2E8A3053}"/>
+                <a16:creationId xmlns:a16="http://schemas.microsoft.com/office/drawing/2014/main" id="{C04E1FBE-0913-4A42-9D04-D21270AD8A1B}"/>
               </a:ext>
             </a:extLst>
           </p:cNvPr>
@@ -12981,7 +12981,7 @@
           <p:cNvPr id="33" name="">
             <a:extLst xmlns:a="http://schemas.openxmlformats.org/drawingml/2006/main">
               <a:ext uri="{FF2B5EF4-FFF2-40B4-BE49-F238E27FC236}">
-                <a16:creationId xmlns:a16="http://schemas.microsoft.com/office/drawing/2014/main" id="{C86ACBC0-592C-4612-89B9-B6C486DBC9A3}"/>
+                <a16:creationId xmlns:a16="http://schemas.microsoft.com/office/drawing/2014/main" id="{99A7144C-B8FB-405E-9A80-8C69CB9C4192}"/>
               </a:ext>
             </a:extLst>
           </p:cNvPr>
@@ -13045,7 +13045,7 @@
           <p:cNvPr id="34" name="">
             <a:extLst xmlns:a="http://schemas.openxmlformats.org/drawingml/2006/main">
               <a:ext uri="{FF2B5EF4-FFF2-40B4-BE49-F238E27FC236}">
-                <a16:creationId xmlns:a16="http://schemas.microsoft.com/office/drawing/2014/main" id="{5E550DB8-7A30-40F0-8731-659EDF71801B}"/>
+                <a16:creationId xmlns:a16="http://schemas.microsoft.com/office/drawing/2014/main" id="{9CDB8CB3-C7FD-4C5D-B403-4AFBFB210C92}"/>
               </a:ext>
             </a:extLst>
           </p:cNvPr>
@@ -13109,7 +13109,7 @@
           <p:cNvPr id="35" name="">
             <a:extLst xmlns:a="http://schemas.openxmlformats.org/drawingml/2006/main">
               <a:ext uri="{FF2B5EF4-FFF2-40B4-BE49-F238E27FC236}">
-                <a16:creationId xmlns:a16="http://schemas.microsoft.com/office/drawing/2014/main" id="{53B5D5DE-AA4C-4EDB-B27E-921E2A576682}"/>
+                <a16:creationId xmlns:a16="http://schemas.microsoft.com/office/drawing/2014/main" id="{05719118-2BF7-46F4-A08F-3D99214E8FF3}"/>
               </a:ext>
             </a:extLst>
           </p:cNvPr>
@@ -13142,7 +13142,7 @@
           <p:cNvPr id="36" name="">
             <a:extLst xmlns:a="http://schemas.openxmlformats.org/drawingml/2006/main">
               <a:ext uri="{FF2B5EF4-FFF2-40B4-BE49-F238E27FC236}">
-                <a16:creationId xmlns:a16="http://schemas.microsoft.com/office/drawing/2014/main" id="{088891B1-D6B1-4221-9E63-952923F5350F}"/>
+                <a16:creationId xmlns:a16="http://schemas.microsoft.com/office/drawing/2014/main" id="{E0A1D9C7-2C1D-4BF7-B5AF-25C8DAA6175A}"/>
               </a:ext>
             </a:extLst>
           </p:cNvPr>
@@ -13206,7 +13206,7 @@
           <p:cNvPr id="37" name="">
             <a:extLst xmlns:a="http://schemas.openxmlformats.org/drawingml/2006/main">
               <a:ext uri="{FF2B5EF4-FFF2-40B4-BE49-F238E27FC236}">
-                <a16:creationId xmlns:a16="http://schemas.microsoft.com/office/drawing/2014/main" id="{F8D01EB4-7CEE-418A-B039-EC12D85F00E3}"/>
+                <a16:creationId xmlns:a16="http://schemas.microsoft.com/office/drawing/2014/main" id="{0B3395BF-A66D-41E3-9203-D8C0381014DF}"/>
               </a:ext>
             </a:extLst>
           </p:cNvPr>
@@ -13316,7 +13316,7 @@
           <p:cNvPr id="38" name="">
             <a:extLst xmlns:a="http://schemas.openxmlformats.org/drawingml/2006/main">
               <a:ext uri="{FF2B5EF4-FFF2-40B4-BE49-F238E27FC236}">
-                <a16:creationId xmlns:a16="http://schemas.microsoft.com/office/drawing/2014/main" id="{1A14706C-777F-4A31-9A2A-CA0C33B4DEAB}"/>
+                <a16:creationId xmlns:a16="http://schemas.microsoft.com/office/drawing/2014/main" id="{0EFAA199-CE2F-4084-91E8-9F1C71661960}"/>
               </a:ext>
             </a:extLst>
           </p:cNvPr>
@@ -13428,7 +13428,7 @@
                 <a:ea typeface="Lato"/>
                 <a:cs typeface="Lato"/>
               </a:rPr>
-              <a:t>So sánh với kết quả công bố</a:t>
+              <a:t>Tóm tắt kết quả chạy thử</a:t>
             </a:r>
           </a:p>
         </p:txBody>
@@ -13438,7 +13438,7 @@
           <p:cNvPr id="5" name="explicit white background">
             <a:extLst xmlns:a="http://schemas.openxmlformats.org/drawingml/2006/main">
               <a:ext uri="{FF2B5EF4-FFF2-40B4-BE49-F238E27FC236}">
-                <a16:creationId xmlns:a16="http://schemas.microsoft.com/office/drawing/2014/main" id="{16CC5839-0C87-48FE-B8EE-746F79665EEF}"/>
+                <a16:creationId xmlns:a16="http://schemas.microsoft.com/office/drawing/2014/main" id="{5353A3A8-33CF-4631-B2FE-9997247212C8}"/>
               </a:ext>
             </a:extLst>
           </p:cNvPr>
@@ -13471,7 +13471,7 @@
           <p:cNvPr id="6" name="HUST red title bar">
             <a:extLst xmlns:a="http://schemas.openxmlformats.org/drawingml/2006/main">
               <a:ext uri="{FF2B5EF4-FFF2-40B4-BE49-F238E27FC236}">
-                <a16:creationId xmlns:a16="http://schemas.microsoft.com/office/drawing/2014/main" id="{1D7D07CE-378F-4E44-950C-1F033A93745D}"/>
+                <a16:creationId xmlns:a16="http://schemas.microsoft.com/office/drawing/2014/main" id="{E2435855-9244-4DAF-807E-394043ED5A42}"/>
               </a:ext>
             </a:extLst>
           </p:cNvPr>
@@ -13504,7 +13504,7 @@
           <p:cNvPr id="7" name="HUST gold divider">
             <a:extLst xmlns:a="http://schemas.openxmlformats.org/drawingml/2006/main">
               <a:ext uri="{FF2B5EF4-FFF2-40B4-BE49-F238E27FC236}">
-                <a16:creationId xmlns:a16="http://schemas.microsoft.com/office/drawing/2014/main" id="{E2CF32B0-C43B-4199-8409-74B5141DCD67}"/>
+                <a16:creationId xmlns:a16="http://schemas.microsoft.com/office/drawing/2014/main" id="{256B3F6A-DF1F-48C4-987C-2F62110873B7}"/>
               </a:ext>
             </a:extLst>
           </p:cNvPr>
@@ -13537,7 +13537,7 @@
           <p:cNvPr id="8" name="">
             <a:extLst xmlns:a="http://schemas.openxmlformats.org/drawingml/2006/main">
               <a:ext uri="{FF2B5EF4-FFF2-40B4-BE49-F238E27FC236}">
-                <a16:creationId xmlns:a16="http://schemas.microsoft.com/office/drawing/2014/main" id="{101C58F9-B63A-47AA-9119-57064F8326AA}"/>
+                <a16:creationId xmlns:a16="http://schemas.microsoft.com/office/drawing/2014/main" id="{72071964-1C3E-41C5-96FD-1B2F71B1B093}"/>
               </a:ext>
             </a:extLst>
           </p:cNvPr>
@@ -13601,7 +13601,7 @@
           <p:cNvPr id="9" name="">
             <a:extLst xmlns:a="http://schemas.openxmlformats.org/drawingml/2006/main">
               <a:ext uri="{FF2B5EF4-FFF2-40B4-BE49-F238E27FC236}">
-                <a16:creationId xmlns:a16="http://schemas.microsoft.com/office/drawing/2014/main" id="{52EC9E9B-BE7C-4B74-B7A3-FFE0B75BB077}"/>
+                <a16:creationId xmlns:a16="http://schemas.microsoft.com/office/drawing/2014/main" id="{B5781D68-5D49-4E52-B2C8-B73A742E57EB}"/>
               </a:ext>
             </a:extLst>
           </p:cNvPr>
@@ -13634,7 +13634,7 @@
           <p:cNvPr id="10" name="">
             <a:extLst xmlns:a="http://schemas.openxmlformats.org/drawingml/2006/main">
               <a:ext uri="{FF2B5EF4-FFF2-40B4-BE49-F238E27FC236}">
-                <a16:creationId xmlns:a16="http://schemas.microsoft.com/office/drawing/2014/main" id="{622D9354-0949-419D-B26A-08073DCE2BDD}"/>
+                <a16:creationId xmlns:a16="http://schemas.microsoft.com/office/drawing/2014/main" id="{669EAA6A-3576-4814-88FC-6FBAC567FC61}"/>
               </a:ext>
             </a:extLst>
           </p:cNvPr>
@@ -13667,7 +13667,7 @@
           <p:cNvPr id="11" name="">
             <a:extLst xmlns:a="http://schemas.openxmlformats.org/drawingml/2006/main">
               <a:ext uri="{FF2B5EF4-FFF2-40B4-BE49-F238E27FC236}">
-                <a16:creationId xmlns:a16="http://schemas.microsoft.com/office/drawing/2014/main" id="{B343C244-4F99-4A86-A6FB-A020123EA48A}"/>
+                <a16:creationId xmlns:a16="http://schemas.microsoft.com/office/drawing/2014/main" id="{7B058241-D95A-4F96-AF82-537FBF3344A9}"/>
               </a:ext>
             </a:extLst>
           </p:cNvPr>
@@ -13731,7 +13731,7 @@
           <p:cNvPr id="12" name="">
             <a:extLst xmlns:a="http://schemas.openxmlformats.org/drawingml/2006/main">
               <a:ext uri="{FF2B5EF4-FFF2-40B4-BE49-F238E27FC236}">
-                <a16:creationId xmlns:a16="http://schemas.microsoft.com/office/drawing/2014/main" id="{C19FA35F-088D-4D2C-9E72-8C7272ACC0F3}"/>
+                <a16:creationId xmlns:a16="http://schemas.microsoft.com/office/drawing/2014/main" id="{4B9C25E1-D366-41FD-8101-3CDD67A52F48}"/>
               </a:ext>
             </a:extLst>
           </p:cNvPr>
@@ -13785,7 +13785,7 @@
                 <a:ea typeface="Calibri"/>
                 <a:cs typeface="Calibri"/>
               </a:rPr>
-              <a:t>Bài báo</a:t>
+              <a:t>Kết quả local</a:t>
             </a:r>
           </a:p>
         </p:txBody>
@@ -13795,7 +13795,7 @@
           <p:cNvPr id="13" name="">
             <a:extLst xmlns:a="http://schemas.openxmlformats.org/drawingml/2006/main">
               <a:ext uri="{FF2B5EF4-FFF2-40B4-BE49-F238E27FC236}">
-                <a16:creationId xmlns:a16="http://schemas.microsoft.com/office/drawing/2014/main" id="{249D1630-E9B5-40C8-A00E-886736E16FE5}"/>
+                <a16:creationId xmlns:a16="http://schemas.microsoft.com/office/drawing/2014/main" id="{69CD307D-1427-4B94-BEAE-549D0723E6D5}"/>
               </a:ext>
             </a:extLst>
           </p:cNvPr>
@@ -13849,7 +13849,7 @@
                 <a:ea typeface="Calibri"/>
                 <a:cs typeface="Calibri"/>
               </a:rPr>
-              <a:t>Chạy thử local</a:t>
+              <a:t>Ý nghĩa</a:t>
             </a:r>
           </a:p>
         </p:txBody>
@@ -13859,7 +13859,7 @@
           <p:cNvPr id="14" name="">
             <a:extLst xmlns:a="http://schemas.openxmlformats.org/drawingml/2006/main">
               <a:ext uri="{FF2B5EF4-FFF2-40B4-BE49-F238E27FC236}">
-                <a16:creationId xmlns:a16="http://schemas.microsoft.com/office/drawing/2014/main" id="{0AD97CEC-4269-41BB-9087-3FD593FDF442}"/>
+                <a16:creationId xmlns:a16="http://schemas.microsoft.com/office/drawing/2014/main" id="{C8E22B1D-DDF5-4B74-9645-ADC397337BAC}"/>
               </a:ext>
             </a:extLst>
           </p:cNvPr>
@@ -13892,7 +13892,7 @@
           <p:cNvPr id="15" name="">
             <a:extLst xmlns:a="http://schemas.openxmlformats.org/drawingml/2006/main">
               <a:ext uri="{FF2B5EF4-FFF2-40B4-BE49-F238E27FC236}">
-                <a16:creationId xmlns:a16="http://schemas.microsoft.com/office/drawing/2014/main" id="{42C0AACE-F29A-4340-BD6F-ADD8FF3F31BC}"/>
+                <a16:creationId xmlns:a16="http://schemas.microsoft.com/office/drawing/2014/main" id="{5018D4D1-CDB3-40EC-BDBB-B7D64CADDB67}"/>
               </a:ext>
             </a:extLst>
           </p:cNvPr>
@@ -13956,7 +13956,7 @@
           <p:cNvPr id="16" name="">
             <a:extLst xmlns:a="http://schemas.openxmlformats.org/drawingml/2006/main">
               <a:ext uri="{FF2B5EF4-FFF2-40B4-BE49-F238E27FC236}">
-                <a16:creationId xmlns:a16="http://schemas.microsoft.com/office/drawing/2014/main" id="{3F128C3F-DD51-40BB-980F-A155C2DC24EA}"/>
+                <a16:creationId xmlns:a16="http://schemas.microsoft.com/office/drawing/2014/main" id="{805924E1-F5F9-4078-9560-6110607D5943}"/>
               </a:ext>
             </a:extLst>
           </p:cNvPr>
@@ -14010,7 +14010,7 @@
                 <a:ea typeface="Calibri"/>
                 <a:cs typeface="Calibri"/>
               </a:rPr>
-              <a:t>0.99913</a:t>
+              <a:t>0.999831</a:t>
             </a:r>
           </a:p>
         </p:txBody>
@@ -14020,7 +14020,7 @@
           <p:cNvPr id="17" name="">
             <a:extLst xmlns:a="http://schemas.openxmlformats.org/drawingml/2006/main">
               <a:ext uri="{FF2B5EF4-FFF2-40B4-BE49-F238E27FC236}">
-                <a16:creationId xmlns:a16="http://schemas.microsoft.com/office/drawing/2014/main" id="{CE7496AE-A4D0-4909-A595-266C1B54208E}"/>
+                <a16:creationId xmlns:a16="http://schemas.microsoft.com/office/drawing/2014/main" id="{3E325164-644D-48F9-B507-458A471EEC87}"/>
               </a:ext>
             </a:extLst>
           </p:cNvPr>
@@ -14074,7 +14074,7 @@
                 <a:ea typeface="Calibri"/>
                 <a:cs typeface="Calibri"/>
               </a:rPr>
-              <a:t>0.999831</a:t>
+              <a:t>Khả năng xếp hạng rất tốt</a:t>
             </a:r>
           </a:p>
         </p:txBody>
@@ -14084,7 +14084,7 @@
           <p:cNvPr id="18" name="">
             <a:extLst xmlns:a="http://schemas.openxmlformats.org/drawingml/2006/main">
               <a:ext uri="{FF2B5EF4-FFF2-40B4-BE49-F238E27FC236}">
-                <a16:creationId xmlns:a16="http://schemas.microsoft.com/office/drawing/2014/main" id="{9D405242-1B5D-4490-A941-001E40BF368A}"/>
+                <a16:creationId xmlns:a16="http://schemas.microsoft.com/office/drawing/2014/main" id="{35AD9EAA-2935-4243-9705-DBB8EAD83181}"/>
               </a:ext>
             </a:extLst>
           </p:cNvPr>
@@ -14117,7 +14117,7 @@
           <p:cNvPr id="19" name="">
             <a:extLst xmlns:a="http://schemas.openxmlformats.org/drawingml/2006/main">
               <a:ext uri="{FF2B5EF4-FFF2-40B4-BE49-F238E27FC236}">
-                <a16:creationId xmlns:a16="http://schemas.microsoft.com/office/drawing/2014/main" id="{659C4474-6330-453F-92FA-9AE909C572B4}"/>
+                <a16:creationId xmlns:a16="http://schemas.microsoft.com/office/drawing/2014/main" id="{F5CB7D09-9469-49F8-B149-CFEC1621C6E2}"/>
               </a:ext>
             </a:extLst>
           </p:cNvPr>
@@ -14181,7 +14181,7 @@
           <p:cNvPr id="20" name="">
             <a:extLst xmlns:a="http://schemas.openxmlformats.org/drawingml/2006/main">
               <a:ext uri="{FF2B5EF4-FFF2-40B4-BE49-F238E27FC236}">
-                <a16:creationId xmlns:a16="http://schemas.microsoft.com/office/drawing/2014/main" id="{4A97251D-E785-45DA-AA4B-E14A28AB0BFB}"/>
+                <a16:creationId xmlns:a16="http://schemas.microsoft.com/office/drawing/2014/main" id="{46D0EFD6-3C82-4C3E-A57D-154992501E06}"/>
               </a:ext>
             </a:extLst>
           </p:cNvPr>
@@ -14235,7 +14235,7 @@
                 <a:ea typeface="Calibri"/>
                 <a:cs typeface="Calibri"/>
               </a:rPr>
-              <a:t>6622/7179 = 92.2%</a:t>
+              <a:t>996/1077 = 92.48%</a:t>
             </a:r>
           </a:p>
         </p:txBody>
@@ -14245,7 +14245,7 @@
           <p:cNvPr id="21" name="">
             <a:extLst xmlns:a="http://schemas.openxmlformats.org/drawingml/2006/main">
               <a:ext uri="{FF2B5EF4-FFF2-40B4-BE49-F238E27FC236}">
-                <a16:creationId xmlns:a16="http://schemas.microsoft.com/office/drawing/2014/main" id="{4F4EB63A-2CD0-4606-8231-74588525922C}"/>
+                <a16:creationId xmlns:a16="http://schemas.microsoft.com/office/drawing/2014/main" id="{8E1313B4-79BF-4A67-9B3B-5B8EE58E2872}"/>
               </a:ext>
             </a:extLst>
           </p:cNvPr>
@@ -14299,7 +14299,7 @@
                 <a:ea typeface="Calibri"/>
                 <a:cs typeface="Calibri"/>
               </a:rPr>
-              <a:t>996/1077 = 92.48%</a:t>
+              <a:t>Phần lớn variant được gọi tự tin</a:t>
             </a:r>
           </a:p>
         </p:txBody>
@@ -14309,7 +14309,7 @@
           <p:cNvPr id="22" name="">
             <a:extLst xmlns:a="http://schemas.openxmlformats.org/drawingml/2006/main">
               <a:ext uri="{FF2B5EF4-FFF2-40B4-BE49-F238E27FC236}">
-                <a16:creationId xmlns:a16="http://schemas.microsoft.com/office/drawing/2014/main" id="{8E2BDA97-B501-4FCE-AE76-18BC8A6D4F72}"/>
+                <a16:creationId xmlns:a16="http://schemas.microsoft.com/office/drawing/2014/main" id="{B5896B3E-B16B-4D2E-AF72-A9FF2A0BA112}"/>
               </a:ext>
             </a:extLst>
           </p:cNvPr>
@@ -14342,7 +14342,7 @@
           <p:cNvPr id="23" name="">
             <a:extLst xmlns:a="http://schemas.openxmlformats.org/drawingml/2006/main">
               <a:ext uri="{FF2B5EF4-FFF2-40B4-BE49-F238E27FC236}">
-                <a16:creationId xmlns:a16="http://schemas.microsoft.com/office/drawing/2014/main" id="{22B4F617-63E2-42ED-923F-5339C97B92A0}"/>
+                <a16:creationId xmlns:a16="http://schemas.microsoft.com/office/drawing/2014/main" id="{DB8DB2AA-55AC-49F9-AEC6-ED00528910D7}"/>
               </a:ext>
             </a:extLst>
           </p:cNvPr>
@@ -14406,7 +14406,7 @@
           <p:cNvPr id="24" name="">
             <a:extLst xmlns:a="http://schemas.openxmlformats.org/drawingml/2006/main">
               <a:ext uri="{FF2B5EF4-FFF2-40B4-BE49-F238E27FC236}">
-                <a16:creationId xmlns:a16="http://schemas.microsoft.com/office/drawing/2014/main" id="{EC24D77C-B286-4B5D-8CBC-A413E515CCB2}"/>
+                <a16:creationId xmlns:a16="http://schemas.microsoft.com/office/drawing/2014/main" id="{BFE21E2B-0C40-4DFE-9E86-AF97968EF20A}"/>
               </a:ext>
             </a:extLst>
           </p:cNvPr>
@@ -14470,7 +14470,7 @@
           <p:cNvPr id="25" name="">
             <a:extLst xmlns:a="http://schemas.openxmlformats.org/drawingml/2006/main">
               <a:ext uri="{FF2B5EF4-FFF2-40B4-BE49-F238E27FC236}">
-                <a16:creationId xmlns:a16="http://schemas.microsoft.com/office/drawing/2014/main" id="{B39340DE-3E2E-448B-A57F-F3CBBB4E9C0E}"/>
+                <a16:creationId xmlns:a16="http://schemas.microsoft.com/office/drawing/2014/main" id="{6199A179-4490-462C-8686-EDBCCBC26F82}"/>
               </a:ext>
             </a:extLst>
           </p:cNvPr>
@@ -14524,7 +14524,7 @@
                 <a:ea typeface="Calibri"/>
                 <a:cs typeface="Calibri"/>
               </a:rPr>
-              <a:t>0</a:t>
+              <a:t>Không có Not present lọt High confidence</a:t>
             </a:r>
           </a:p>
         </p:txBody>
@@ -14534,7 +14534,7 @@
           <p:cNvPr id="26" name="">
             <a:extLst xmlns:a="http://schemas.openxmlformats.org/drawingml/2006/main">
               <a:ext uri="{FF2B5EF4-FFF2-40B4-BE49-F238E27FC236}">
-                <a16:creationId xmlns:a16="http://schemas.microsoft.com/office/drawing/2014/main" id="{418FC126-2AFD-420F-A994-8F09692C222B}"/>
+                <a16:creationId xmlns:a16="http://schemas.microsoft.com/office/drawing/2014/main" id="{366D72BD-F498-4B32-AB28-64A22BC18C7D}"/>
               </a:ext>
             </a:extLst>
           </p:cNvPr>
@@ -14567,7 +14567,7 @@
           <p:cNvPr id="27" name="">
             <a:extLst xmlns:a="http://schemas.openxmlformats.org/drawingml/2006/main">
               <a:ext uri="{FF2B5EF4-FFF2-40B4-BE49-F238E27FC236}">
-                <a16:creationId xmlns:a16="http://schemas.microsoft.com/office/drawing/2014/main" id="{00B46F61-35A8-4234-8BDE-66828F5C937B}"/>
+                <a16:creationId xmlns:a16="http://schemas.microsoft.com/office/drawing/2014/main" id="{5504BC26-A0A7-4A0C-A332-14DF697502EF}"/>
               </a:ext>
             </a:extLst>
           </p:cNvPr>
@@ -14631,7 +14631,7 @@
           <p:cNvPr id="28" name="">
             <a:extLst xmlns:a="http://schemas.openxmlformats.org/drawingml/2006/main">
               <a:ext uri="{FF2B5EF4-FFF2-40B4-BE49-F238E27FC236}">
-                <a16:creationId xmlns:a16="http://schemas.microsoft.com/office/drawing/2014/main" id="{19947B81-5DFF-4D78-95C0-2FECC5DC69C9}"/>
+                <a16:creationId xmlns:a16="http://schemas.microsoft.com/office/drawing/2014/main" id="{772BEC7F-0355-4330-B2F5-A56AA05F44F5}"/>
               </a:ext>
             </a:extLst>
           </p:cNvPr>
@@ -14685,7 +14685,7 @@
                 <a:ea typeface="Calibri"/>
                 <a:cs typeface="Calibri"/>
               </a:rPr>
-              <a:t>44/7179 = 0.61%</a:t>
+              <a:t>4/1077 = 0.37%</a:t>
             </a:r>
           </a:p>
         </p:txBody>
@@ -14695,7 +14695,7 @@
           <p:cNvPr id="29" name="">
             <a:extLst xmlns:a="http://schemas.openxmlformats.org/drawingml/2006/main">
               <a:ext uri="{FF2B5EF4-FFF2-40B4-BE49-F238E27FC236}">
-                <a16:creationId xmlns:a16="http://schemas.microsoft.com/office/drawing/2014/main" id="{67FCBC7E-6EA5-4264-930D-E874FF43F80F}"/>
+                <a16:creationId xmlns:a16="http://schemas.microsoft.com/office/drawing/2014/main" id="{7DCA676D-85EF-40C8-944B-F7B27FC722A7}"/>
               </a:ext>
             </a:extLst>
           </p:cNvPr>
@@ -14749,7 +14749,7 @@
                 <a:ea typeface="Calibri"/>
                 <a:cs typeface="Calibri"/>
               </a:rPr>
-              <a:t>4/1077 = 0.37%</a:t>
+              <a:t>Một số Present bị giữ lại Low confidence</a:t>
             </a:r>
           </a:p>
         </p:txBody>
@@ -14759,7 +14759,7 @@
           <p:cNvPr id="30" name="">
             <a:extLst xmlns:a="http://schemas.openxmlformats.org/drawingml/2006/main">
               <a:ext uri="{FF2B5EF4-FFF2-40B4-BE49-F238E27FC236}">
-                <a16:creationId xmlns:a16="http://schemas.microsoft.com/office/drawing/2014/main" id="{6F6E50E9-F184-4788-A514-50601FC05127}"/>
+                <a16:creationId xmlns:a16="http://schemas.microsoft.com/office/drawing/2014/main" id="{0E6C7356-1802-488E-AC63-5D80FE4597EA}"/>
               </a:ext>
             </a:extLst>
           </p:cNvPr>
@@ -14792,7 +14792,7 @@
           <p:cNvPr id="31" name="">
             <a:extLst xmlns:a="http://schemas.openxmlformats.org/drawingml/2006/main">
               <a:ext uri="{FF2B5EF4-FFF2-40B4-BE49-F238E27FC236}">
-                <a16:creationId xmlns:a16="http://schemas.microsoft.com/office/drawing/2014/main" id="{57EB04E0-7EE7-4219-B571-46F33C3D49B3}"/>
+                <a16:creationId xmlns:a16="http://schemas.microsoft.com/office/drawing/2014/main" id="{FAC9C639-4C6E-4BC1-B3F8-E40212C469D6}"/>
               </a:ext>
             </a:extLst>
           </p:cNvPr>
@@ -14846,7 +14846,7 @@
                 <a:ea typeface="Calibri"/>
                 <a:cs typeface="Calibri"/>
               </a:rPr>
-              <a:t>Accuracy</a:t>
+              <a:t>CV AUC mean</a:t>
             </a:r>
           </a:p>
         </p:txBody>
@@ -14856,7 +14856,7 @@
           <p:cNvPr id="32" name="">
             <a:extLst xmlns:a="http://schemas.openxmlformats.org/drawingml/2006/main">
               <a:ext uri="{FF2B5EF4-FFF2-40B4-BE49-F238E27FC236}">
-                <a16:creationId xmlns:a16="http://schemas.microsoft.com/office/drawing/2014/main" id="{DB414F94-B401-406D-9AB9-FFC74168EEB6}"/>
+                <a16:creationId xmlns:a16="http://schemas.microsoft.com/office/drawing/2014/main" id="{DEFC5318-9628-4BDF-9C01-8C3D75129D22}"/>
               </a:ext>
             </a:extLst>
           </p:cNvPr>
@@ -14910,7 +14910,7 @@
                 <a:ea typeface="Calibri"/>
                 <a:cs typeface="Calibri"/>
               </a:rPr>
-              <a:t>99.4%</a:t>
+              <a:t>0.999776</a:t>
             </a:r>
           </a:p>
         </p:txBody>
@@ -14920,7 +14920,7 @@
           <p:cNvPr id="33" name="">
             <a:extLst xmlns:a="http://schemas.openxmlformats.org/drawingml/2006/main">
               <a:ext uri="{FF2B5EF4-FFF2-40B4-BE49-F238E27FC236}">
-                <a16:creationId xmlns:a16="http://schemas.microsoft.com/office/drawing/2014/main" id="{1AC8983C-40F5-4941-80A8-5B27CA8050A5}"/>
+                <a16:creationId xmlns:a16="http://schemas.microsoft.com/office/drawing/2014/main" id="{4F5DCC42-94D1-435B-8F68-E055F6452740}"/>
               </a:ext>
             </a:extLst>
           </p:cNvPr>
@@ -14974,7 +14974,7 @@
                 <a:ea typeface="Calibri"/>
                 <a:cs typeface="Calibri"/>
               </a:rPr>
-              <a:t>99.63%</a:t>
+              <a:t>Ổn định trên kiểm tra 10-fold</a:t>
             </a:r>
           </a:p>
         </p:txBody>
@@ -14984,7 +14984,7 @@
           <p:cNvPr id="34" name="">
             <a:extLst xmlns:a="http://schemas.openxmlformats.org/drawingml/2006/main">
               <a:ext uri="{FF2B5EF4-FFF2-40B4-BE49-F238E27FC236}">
-                <a16:creationId xmlns:a16="http://schemas.microsoft.com/office/drawing/2014/main" id="{6F046665-3115-4CF9-9EF8-BF843D521FFF}"/>
+                <a16:creationId xmlns:a16="http://schemas.microsoft.com/office/drawing/2014/main" id="{AD534AF0-13CF-49D5-91A3-13F4E29B98C5}"/>
               </a:ext>
             </a:extLst>
           </p:cNvPr>
@@ -15017,7 +15017,7 @@
           <p:cNvPr id="35" name="">
             <a:extLst xmlns:a="http://schemas.openxmlformats.org/drawingml/2006/main">
               <a:ext uri="{FF2B5EF4-FFF2-40B4-BE49-F238E27FC236}">
-                <a16:creationId xmlns:a16="http://schemas.microsoft.com/office/drawing/2014/main" id="{E3F59C28-F4FE-44C2-A9B6-CAB9D565F3DE}"/>
+                <a16:creationId xmlns:a16="http://schemas.microsoft.com/office/drawing/2014/main" id="{447858C2-8226-4EB5-B8CC-829BE9D2D5B4}"/>
               </a:ext>
             </a:extLst>
           </p:cNvPr>
@@ -15081,7 +15081,7 @@
           <p:cNvPr id="36" name="">
             <a:extLst xmlns:a="http://schemas.openxmlformats.org/drawingml/2006/main">
               <a:ext uri="{FF2B5EF4-FFF2-40B4-BE49-F238E27FC236}">
-                <a16:creationId xmlns:a16="http://schemas.microsoft.com/office/drawing/2014/main" id="{1C5863FF-20FE-42FA-887B-E38BD5974BFD}"/>
+                <a16:creationId xmlns:a16="http://schemas.microsoft.com/office/drawing/2014/main" id="{EBA77A44-A588-42C0-8C19-20989D5861D1}"/>
               </a:ext>
             </a:extLst>
           </p:cNvPr>
@@ -15135,7 +15135,7 @@
                 <a:ea typeface="Calibri"/>
                 <a:cs typeface="Calibri"/>
               </a:rPr>
-              <a:t>Kết quả chạy thử bám rất sát mục tiêu của bài báo: tỷ lệ High confidence khoảng 92%, FP = 0. AUC local cao hơn nhẹ do split ngẫu nhiên và pipeline sklearn có thể khác đúng cấu hình gốc.</a:t>
+              <a:t>Kết quả local cho thấy pipeline phù hợp với mục tiêu bảo thủ: giữ FP = 0 trên Test và vẫn gọi High confidence cho phần lớn variant thật. Đây là kết quả thử nghiệm, cần kiểm tra thêm trên dữ liệu độc lập.</a:t>
             </a:r>
           </a:p>
         </p:txBody>
@@ -15145,7 +15145,7 @@
           <p:cNvPr id="37" name="">
             <a:extLst xmlns:a="http://schemas.openxmlformats.org/drawingml/2006/main">
               <a:ext uri="{FF2B5EF4-FFF2-40B4-BE49-F238E27FC236}">
-                <a16:creationId xmlns:a16="http://schemas.microsoft.com/office/drawing/2014/main" id="{4C00AE15-C111-4D6A-93B9-1B50C5A4B093}"/>
+                <a16:creationId xmlns:a16="http://schemas.microsoft.com/office/drawing/2014/main" id="{C427157D-3139-4CDD-AD38-CA56263034B3}"/>
               </a:ext>
             </a:extLst>
           </p:cNvPr>
@@ -15199,7 +15199,7 @@
                 <a:ea typeface="Calibri"/>
                 <a:cs typeface="Calibri"/>
               </a:rPr>
-              <a:t>Bài báo: BMC Genomics 2018, 19:263; PMID 29665779; PMCID PMC5904977</a:t>
+              <a:t>Kết quả local từ script D:\A\train_conservative_threshold.py</a:t>
             </a:r>
           </a:p>
         </p:txBody>
@@ -15275,7 +15275,7 @@
           <p:cNvPr id="5" name="explicit white background">
             <a:extLst xmlns:a="http://schemas.openxmlformats.org/drawingml/2006/main">
               <a:ext uri="{FF2B5EF4-FFF2-40B4-BE49-F238E27FC236}">
-                <a16:creationId xmlns:a16="http://schemas.microsoft.com/office/drawing/2014/main" id="{A9AC4FFE-6297-49D2-BC7D-6E34E7D060DE}"/>
+                <a16:creationId xmlns:a16="http://schemas.microsoft.com/office/drawing/2014/main" id="{705E00EF-CD11-4503-B2CF-EE1F7EA1165D}"/>
               </a:ext>
             </a:extLst>
           </p:cNvPr>
@@ -15308,7 +15308,7 @@
           <p:cNvPr id="6" name="HUST red title bar">
             <a:extLst xmlns:a="http://schemas.openxmlformats.org/drawingml/2006/main">
               <a:ext uri="{FF2B5EF4-FFF2-40B4-BE49-F238E27FC236}">
-                <a16:creationId xmlns:a16="http://schemas.microsoft.com/office/drawing/2014/main" id="{BE6951D2-9300-48C6-8B1A-315BC345C8F1}"/>
+                <a16:creationId xmlns:a16="http://schemas.microsoft.com/office/drawing/2014/main" id="{E84FBC15-D3C7-419B-8F8E-182AC6774C97}"/>
               </a:ext>
             </a:extLst>
           </p:cNvPr>
@@ -15341,7 +15341,7 @@
           <p:cNvPr id="7" name="HUST gold divider">
             <a:extLst xmlns:a="http://schemas.openxmlformats.org/drawingml/2006/main">
               <a:ext uri="{FF2B5EF4-FFF2-40B4-BE49-F238E27FC236}">
-                <a16:creationId xmlns:a16="http://schemas.microsoft.com/office/drawing/2014/main" id="{16ED18A9-3185-40CF-BB5E-845ED7AC9AFA}"/>
+                <a16:creationId xmlns:a16="http://schemas.microsoft.com/office/drawing/2014/main" id="{96B7E82B-A0E3-487E-913F-9E73FE863C15}"/>
               </a:ext>
             </a:extLst>
           </p:cNvPr>
@@ -15374,7 +15374,7 @@
           <p:cNvPr id="8" name="">
             <a:extLst xmlns:a="http://schemas.openxmlformats.org/drawingml/2006/main">
               <a:ext uri="{FF2B5EF4-FFF2-40B4-BE49-F238E27FC236}">
-                <a16:creationId xmlns:a16="http://schemas.microsoft.com/office/drawing/2014/main" id="{19F71038-2C21-440A-A6CC-AC9FD1ED64A0}"/>
+                <a16:creationId xmlns:a16="http://schemas.microsoft.com/office/drawing/2014/main" id="{6625A313-B9C6-4941-AC9D-18BA153EB949}"/>
               </a:ext>
             </a:extLst>
           </p:cNvPr>
@@ -15438,7 +15438,7 @@
           <p:cNvPr id="9" name="">
             <a:extLst xmlns:a="http://schemas.openxmlformats.org/drawingml/2006/main">
               <a:ext uri="{FF2B5EF4-FFF2-40B4-BE49-F238E27FC236}">
-                <a16:creationId xmlns:a16="http://schemas.microsoft.com/office/drawing/2014/main" id="{97C329F9-8BBD-4EFF-B8F3-807E1DD7B12A}"/>
+                <a16:creationId xmlns:a16="http://schemas.microsoft.com/office/drawing/2014/main" id="{27D6C2CA-9303-4A4E-85B6-F46C77ABFAC0}"/>
               </a:ext>
             </a:extLst>
           </p:cNvPr>
@@ -15471,7 +15471,7 @@
           <p:cNvPr id="10" name="">
             <a:extLst xmlns:a="http://schemas.openxmlformats.org/drawingml/2006/main">
               <a:ext uri="{FF2B5EF4-FFF2-40B4-BE49-F238E27FC236}">
-                <a16:creationId xmlns:a16="http://schemas.microsoft.com/office/drawing/2014/main" id="{09140FBE-0F0F-4DA7-87F3-16CA6C3E2CD1}"/>
+                <a16:creationId xmlns:a16="http://schemas.microsoft.com/office/drawing/2014/main" id="{DE99D546-B711-4E2F-8B12-09ADA6E7F0DC}"/>
               </a:ext>
             </a:extLst>
           </p:cNvPr>
@@ -15504,7 +15504,7 @@
           <p:cNvPr id="11" name="">
             <a:extLst xmlns:a="http://schemas.openxmlformats.org/drawingml/2006/main">
               <a:ext uri="{FF2B5EF4-FFF2-40B4-BE49-F238E27FC236}">
-                <a16:creationId xmlns:a16="http://schemas.microsoft.com/office/drawing/2014/main" id="{AA640792-3C54-4567-A3D3-B775621176FB}"/>
+                <a16:creationId xmlns:a16="http://schemas.microsoft.com/office/drawing/2014/main" id="{898C379C-1D3C-4215-A640-541B12869990}"/>
               </a:ext>
             </a:extLst>
           </p:cNvPr>
@@ -15568,7 +15568,7 @@
           <p:cNvPr id="12" name="">
             <a:extLst xmlns:a="http://schemas.openxmlformats.org/drawingml/2006/main">
               <a:ext uri="{FF2B5EF4-FFF2-40B4-BE49-F238E27FC236}">
-                <a16:creationId xmlns:a16="http://schemas.microsoft.com/office/drawing/2014/main" id="{DEE9DC40-7AE7-4EBE-A57A-911857FFD19F}"/>
+                <a16:creationId xmlns:a16="http://schemas.microsoft.com/office/drawing/2014/main" id="{FFE7D15B-E105-4A17-BCB0-DE26FD63DE67}"/>
               </a:ext>
             </a:extLst>
           </p:cNvPr>
@@ -15632,7 +15632,7 @@
           <p:cNvPr id="13" name="">
             <a:extLst xmlns:a="http://schemas.openxmlformats.org/drawingml/2006/main">
               <a:ext uri="{FF2B5EF4-FFF2-40B4-BE49-F238E27FC236}">
-                <a16:creationId xmlns:a16="http://schemas.microsoft.com/office/drawing/2014/main" id="{2569D4A7-F8DD-4443-B434-7DB2DFA27B06}"/>
+                <a16:creationId xmlns:a16="http://schemas.microsoft.com/office/drawing/2014/main" id="{5FD87C21-EDB1-4120-88AC-63BA1D9F3748}"/>
               </a:ext>
             </a:extLst>
           </p:cNvPr>
@@ -15665,7 +15665,7 @@
           <p:cNvPr id="14" name="">
             <a:extLst xmlns:a="http://schemas.openxmlformats.org/drawingml/2006/main">
               <a:ext uri="{FF2B5EF4-FFF2-40B4-BE49-F238E27FC236}">
-                <a16:creationId xmlns:a16="http://schemas.microsoft.com/office/drawing/2014/main" id="{9A12C2D8-F5C1-4E70-838C-06AC643AE2AC}"/>
+                <a16:creationId xmlns:a16="http://schemas.microsoft.com/office/drawing/2014/main" id="{9018DA7F-776B-44AE-876B-97BDE3ABD373}"/>
               </a:ext>
             </a:extLst>
           </p:cNvPr>
@@ -15729,7 +15729,7 @@
           <p:cNvPr id="15" name="">
             <a:extLst xmlns:a="http://schemas.openxmlformats.org/drawingml/2006/main">
               <a:ext uri="{FF2B5EF4-FFF2-40B4-BE49-F238E27FC236}">
-                <a16:creationId xmlns:a16="http://schemas.microsoft.com/office/drawing/2014/main" id="{F957B712-A433-4250-82B4-851C19C095B6}"/>
+                <a16:creationId xmlns:a16="http://schemas.microsoft.com/office/drawing/2014/main" id="{FBABA0E5-4549-4E8A-9A81-61EBF118A61C}"/>
               </a:ext>
             </a:extLst>
           </p:cNvPr>
@@ -15793,7 +15793,7 @@
           <p:cNvPr id="16" name="">
             <a:extLst xmlns:a="http://schemas.openxmlformats.org/drawingml/2006/main">
               <a:ext uri="{FF2B5EF4-FFF2-40B4-BE49-F238E27FC236}">
-                <a16:creationId xmlns:a16="http://schemas.microsoft.com/office/drawing/2014/main" id="{E7FACC51-2183-4DB2-A46A-15642BDEA93D}"/>
+                <a16:creationId xmlns:a16="http://schemas.microsoft.com/office/drawing/2014/main" id="{2CD4C807-2CBD-40BC-BAAA-21BB5EB2C163}"/>
               </a:ext>
             </a:extLst>
           </p:cNvPr>
@@ -15826,7 +15826,7 @@
           <p:cNvPr id="17" name="">
             <a:extLst xmlns:a="http://schemas.openxmlformats.org/drawingml/2006/main">
               <a:ext uri="{FF2B5EF4-FFF2-40B4-BE49-F238E27FC236}">
-                <a16:creationId xmlns:a16="http://schemas.microsoft.com/office/drawing/2014/main" id="{7AF38C92-3DBC-40B7-8DE6-9E06A362C3F5}"/>
+                <a16:creationId xmlns:a16="http://schemas.microsoft.com/office/drawing/2014/main" id="{A991F35A-3A6E-4E54-A5A8-79D5972101F7}"/>
               </a:ext>
             </a:extLst>
           </p:cNvPr>
@@ -15890,7 +15890,7 @@
           <p:cNvPr id="18" name="">
             <a:extLst xmlns:a="http://schemas.openxmlformats.org/drawingml/2006/main">
               <a:ext uri="{FF2B5EF4-FFF2-40B4-BE49-F238E27FC236}">
-                <a16:creationId xmlns:a16="http://schemas.microsoft.com/office/drawing/2014/main" id="{57A61891-2F99-4B13-885A-B9BBA6CD5660}"/>
+                <a16:creationId xmlns:a16="http://schemas.microsoft.com/office/drawing/2014/main" id="{E1F3621B-E1AA-476B-AD40-314214D6935C}"/>
               </a:ext>
             </a:extLst>
           </p:cNvPr>
@@ -15954,7 +15954,7 @@
           <p:cNvPr id="19" name="">
             <a:extLst xmlns:a="http://schemas.openxmlformats.org/drawingml/2006/main">
               <a:ext uri="{FF2B5EF4-FFF2-40B4-BE49-F238E27FC236}">
-                <a16:creationId xmlns:a16="http://schemas.microsoft.com/office/drawing/2014/main" id="{2535D70D-50BA-47ED-9742-1BF825F21812}"/>
+                <a16:creationId xmlns:a16="http://schemas.microsoft.com/office/drawing/2014/main" id="{37C4E5D8-A945-4BD9-9238-8BB6AA4544E7}"/>
               </a:ext>
             </a:extLst>
           </p:cNvPr>
@@ -15987,7 +15987,7 @@
           <p:cNvPr id="20" name="">
             <a:extLst xmlns:a="http://schemas.openxmlformats.org/drawingml/2006/main">
               <a:ext uri="{FF2B5EF4-FFF2-40B4-BE49-F238E27FC236}">
-                <a16:creationId xmlns:a16="http://schemas.microsoft.com/office/drawing/2014/main" id="{F34E5167-E4D6-4CA6-8D84-81BA827F3D66}"/>
+                <a16:creationId xmlns:a16="http://schemas.microsoft.com/office/drawing/2014/main" id="{8DBD482B-E5CA-446A-B122-AFBC7B483E96}"/>
               </a:ext>
             </a:extLst>
           </p:cNvPr>
@@ -16051,7 +16051,7 @@
           <p:cNvPr id="21" name="">
             <a:extLst xmlns:a="http://schemas.openxmlformats.org/drawingml/2006/main">
               <a:ext uri="{FF2B5EF4-FFF2-40B4-BE49-F238E27FC236}">
-                <a16:creationId xmlns:a16="http://schemas.microsoft.com/office/drawing/2014/main" id="{6750DCFC-CB48-42DE-B43F-635591B3BC49}"/>
+                <a16:creationId xmlns:a16="http://schemas.microsoft.com/office/drawing/2014/main" id="{3A930936-280E-48BD-8E26-8B2EC68503E6}"/>
               </a:ext>
             </a:extLst>
           </p:cNvPr>
@@ -16242,7 +16242,7 @@
           <p:cNvPr id="5" name="explicit white background">
             <a:extLst xmlns:a="http://schemas.openxmlformats.org/drawingml/2006/main">
               <a:ext uri="{FF2B5EF4-FFF2-40B4-BE49-F238E27FC236}">
-                <a16:creationId xmlns:a16="http://schemas.microsoft.com/office/drawing/2014/main" id="{5A9C0812-397B-4382-A84F-38D98C6E2778}"/>
+                <a16:creationId xmlns:a16="http://schemas.microsoft.com/office/drawing/2014/main" id="{DE76133E-7AE6-4B71-A455-FADBEBCA2A05}"/>
               </a:ext>
             </a:extLst>
           </p:cNvPr>
@@ -16275,7 +16275,7 @@
           <p:cNvPr id="6" name="HUST red title bar">
             <a:extLst xmlns:a="http://schemas.openxmlformats.org/drawingml/2006/main">
               <a:ext uri="{FF2B5EF4-FFF2-40B4-BE49-F238E27FC236}">
-                <a16:creationId xmlns:a16="http://schemas.microsoft.com/office/drawing/2014/main" id="{B1B6E118-4D71-4B94-90FF-722A96CCD575}"/>
+                <a16:creationId xmlns:a16="http://schemas.microsoft.com/office/drawing/2014/main" id="{C8DBD40B-9C20-4024-B01B-9DD78FCBA2CD}"/>
               </a:ext>
             </a:extLst>
           </p:cNvPr>
@@ -16308,7 +16308,7 @@
           <p:cNvPr id="7" name="HUST gold divider">
             <a:extLst xmlns:a="http://schemas.openxmlformats.org/drawingml/2006/main">
               <a:ext uri="{FF2B5EF4-FFF2-40B4-BE49-F238E27FC236}">
-                <a16:creationId xmlns:a16="http://schemas.microsoft.com/office/drawing/2014/main" id="{9640C9B0-66FB-476E-A946-FAD97B9CFF42}"/>
+                <a16:creationId xmlns:a16="http://schemas.microsoft.com/office/drawing/2014/main" id="{8A6F64D7-B3EA-4444-8A07-A0458A1051E0}"/>
               </a:ext>
             </a:extLst>
           </p:cNvPr>
@@ -16341,7 +16341,7 @@
           <p:cNvPr id="8" name="">
             <a:extLst xmlns:a="http://schemas.openxmlformats.org/drawingml/2006/main">
               <a:ext uri="{FF2B5EF4-FFF2-40B4-BE49-F238E27FC236}">
-                <a16:creationId xmlns:a16="http://schemas.microsoft.com/office/drawing/2014/main" id="{44AEEE5F-DAEB-423A-884B-C4541B1BE487}"/>
+                <a16:creationId xmlns:a16="http://schemas.microsoft.com/office/drawing/2014/main" id="{0B92A5FC-CEBF-493A-9C23-9532D8DB5E54}"/>
               </a:ext>
             </a:extLst>
           </p:cNvPr>
@@ -16405,7 +16405,7 @@
           <p:cNvPr id="9" name="">
             <a:extLst xmlns:a="http://schemas.openxmlformats.org/drawingml/2006/main">
               <a:ext uri="{FF2B5EF4-FFF2-40B4-BE49-F238E27FC236}">
-                <a16:creationId xmlns:a16="http://schemas.microsoft.com/office/drawing/2014/main" id="{07ABDA01-571D-4811-AAE0-159DCE302709}"/>
+                <a16:creationId xmlns:a16="http://schemas.microsoft.com/office/drawing/2014/main" id="{B6B08941-FEA4-45E5-94D8-E66104E20ABB}"/>
               </a:ext>
             </a:extLst>
           </p:cNvPr>
@@ -16438,7 +16438,7 @@
           <p:cNvPr id="10" name="">
             <a:extLst xmlns:a="http://schemas.openxmlformats.org/drawingml/2006/main">
               <a:ext uri="{FF2B5EF4-FFF2-40B4-BE49-F238E27FC236}">
-                <a16:creationId xmlns:a16="http://schemas.microsoft.com/office/drawing/2014/main" id="{035C6F17-0CBA-410C-843F-2562139952FE}"/>
+                <a16:creationId xmlns:a16="http://schemas.microsoft.com/office/drawing/2014/main" id="{AF55AC9B-B4CD-42BA-8B6F-5B7247C5F253}"/>
               </a:ext>
             </a:extLst>
           </p:cNvPr>
@@ -16471,7 +16471,7 @@
           <p:cNvPr id="11" name="">
             <a:extLst xmlns:a="http://schemas.openxmlformats.org/drawingml/2006/main">
               <a:ext uri="{FF2B5EF4-FFF2-40B4-BE49-F238E27FC236}">
-                <a16:creationId xmlns:a16="http://schemas.microsoft.com/office/drawing/2014/main" id="{25CFCE98-296A-4BAD-BB1B-5B737ECC3C4A}"/>
+                <a16:creationId xmlns:a16="http://schemas.microsoft.com/office/drawing/2014/main" id="{B13EAEB0-4697-49D7-BAE2-06F1E45687BC}"/>
               </a:ext>
             </a:extLst>
           </p:cNvPr>
@@ -16535,7 +16535,7 @@
           <p:cNvPr id="12" name="">
             <a:extLst xmlns:a="http://schemas.openxmlformats.org/drawingml/2006/main">
               <a:ext uri="{FF2B5EF4-FFF2-40B4-BE49-F238E27FC236}">
-                <a16:creationId xmlns:a16="http://schemas.microsoft.com/office/drawing/2014/main" id="{A678F0A4-3753-4B30-AFCD-E02036CDFC9B}"/>
+                <a16:creationId xmlns:a16="http://schemas.microsoft.com/office/drawing/2014/main" id="{99DB4E38-2EBF-4FCB-B3C7-78E0902932C8}"/>
               </a:ext>
             </a:extLst>
           </p:cNvPr>
@@ -16589,7 +16589,7 @@
                 <a:ea typeface="Calibri"/>
                 <a:cs typeface="Calibri"/>
               </a:rPr>
-              <a:t>- Split local có thể khác bài báo gốc.</a:t>
+              <a:t>- Kết quả phụ thuộc random split local.</a:t>
             </a:r>
           </a:p>
           <a:p xmlns:a="http://schemas.openxmlformats.org/drawingml/2006/main">
@@ -16691,7 +16691,7 @@
           <p:cNvPr id="13" name="">
             <a:extLst xmlns:a="http://schemas.openxmlformats.org/drawingml/2006/main">
               <a:ext uri="{FF2B5EF4-FFF2-40B4-BE49-F238E27FC236}">
-                <a16:creationId xmlns:a16="http://schemas.microsoft.com/office/drawing/2014/main" id="{22B6A0B9-AEB3-455E-B3E1-42F4A8BD2DD6}"/>
+                <a16:creationId xmlns:a16="http://schemas.microsoft.com/office/drawing/2014/main" id="{A2D8F544-F707-4B0D-8863-DB2C7E220146}"/>
               </a:ext>
             </a:extLst>
           </p:cNvPr>
@@ -16724,7 +16724,7 @@
           <p:cNvPr id="14" name="">
             <a:extLst xmlns:a="http://schemas.openxmlformats.org/drawingml/2006/main">
               <a:ext uri="{FF2B5EF4-FFF2-40B4-BE49-F238E27FC236}">
-                <a16:creationId xmlns:a16="http://schemas.microsoft.com/office/drawing/2014/main" id="{3C4CE78F-C10A-414A-B117-22AB9D4049A6}"/>
+                <a16:creationId xmlns:a16="http://schemas.microsoft.com/office/drawing/2014/main" id="{5AD6552D-17D2-4406-903D-4ADD26E9FC11}"/>
               </a:ext>
             </a:extLst>
           </p:cNvPr>
@@ -16788,7 +16788,7 @@
           <p:cNvPr id="15" name="">
             <a:extLst xmlns:a="http://schemas.openxmlformats.org/drawingml/2006/main">
               <a:ext uri="{FF2B5EF4-FFF2-40B4-BE49-F238E27FC236}">
-                <a16:creationId xmlns:a16="http://schemas.microsoft.com/office/drawing/2014/main" id="{868FA0DE-35A9-4C53-AA6E-52F7639F1FB9}"/>
+                <a16:creationId xmlns:a16="http://schemas.microsoft.com/office/drawing/2014/main" id="{B6D96742-C39A-449E-BC54-76287C807009}"/>
               </a:ext>
             </a:extLst>
           </p:cNvPr>
@@ -16944,7 +16944,7 @@
           <p:cNvPr id="16" name="">
             <a:extLst xmlns:a="http://schemas.openxmlformats.org/drawingml/2006/main">
               <a:ext uri="{FF2B5EF4-FFF2-40B4-BE49-F238E27FC236}">
-                <a16:creationId xmlns:a16="http://schemas.microsoft.com/office/drawing/2014/main" id="{B54E3E96-FC95-4A3C-AE2E-408C9059C5E5}"/>
+                <a16:creationId xmlns:a16="http://schemas.microsoft.com/office/drawing/2014/main" id="{2B4BBDD7-C81D-4855-9302-7B664F82120B}"/>
               </a:ext>
             </a:extLst>
           </p:cNvPr>
@@ -16977,7 +16977,7 @@
           <p:cNvPr id="17" name="">
             <a:extLst xmlns:a="http://schemas.openxmlformats.org/drawingml/2006/main">
               <a:ext uri="{FF2B5EF4-FFF2-40B4-BE49-F238E27FC236}">
-                <a16:creationId xmlns:a16="http://schemas.microsoft.com/office/drawing/2014/main" id="{ED3DADB1-1D84-4CE0-9CF9-2C112E9F3A2E}"/>
+                <a16:creationId xmlns:a16="http://schemas.microsoft.com/office/drawing/2014/main" id="{72CA373B-2172-486A-991E-9CAF4F6A9C7D}"/>
               </a:ext>
             </a:extLst>
           </p:cNvPr>

</xml_diff>